<commit_message>
Synchronisation UI/invariants et amÃ©lioration ordre d'exÃ©cution
- Synchronisation des valeurs L et dl_dt_cmd entre UI et invariants
- Encapsulation de la logique de rafraÃ®chissement UI dans build_and_emit_ui_update
- DÃ©placement de l'incrÃ©mentation du temps Ã  la fin de l'itÃ©ration pour cohÃ©rence
- Utilisation de T_boat directement dans IC_L_7 au lieu de _last_val()
- Ajout de flush explicite dans trace_print pour garantir l'ordre d'affichage
- DÃ©placement des calculs de forces avant la construction du contexte partagÃ©
- Ajout de messages de debug pour tracer l'ordre d'exÃ©cution
</commit_message>
<xml_diff>
--- a/simulateur_rov/Ordres de grandeur.pptx
+++ b/simulateur_rov/Ordres de grandeur.pptx
@@ -128,18 +128,26 @@
   <pc:docChgLst>
     <pc:chgData name="Jacques Delort" userId="338bbbaa6367577a" providerId="LiveId" clId="{29EEF4E2-F752-45CC-A7DF-F1AD94B64117}"/>
     <pc:docChg chg="undo custSel addSld modSld">
-      <pc:chgData name="Jacques Delort" userId="338bbbaa6367577a" providerId="LiveId" clId="{29EEF4E2-F752-45CC-A7DF-F1AD94B64117}" dt="2026-03-09T08:22:34.040" v="163" actId="13822"/>
+      <pc:chgData name="Jacques Delort" userId="338bbbaa6367577a" providerId="LiveId" clId="{29EEF4E2-F752-45CC-A7DF-F1AD94B64117}" dt="2026-03-12T14:59:48.166" v="186" actId="14100"/>
       <pc:docMkLst>
         <pc:docMk/>
       </pc:docMkLst>
       <pc:sldChg chg="addSp delSp modSp new mod">
-        <pc:chgData name="Jacques Delort" userId="338bbbaa6367577a" providerId="LiveId" clId="{29EEF4E2-F752-45CC-A7DF-F1AD94B64117}" dt="2026-03-09T08:22:34.040" v="163" actId="13822"/>
+        <pc:chgData name="Jacques Delort" userId="338bbbaa6367577a" providerId="LiveId" clId="{29EEF4E2-F752-45CC-A7DF-F1AD94B64117}" dt="2026-03-12T14:59:48.166" v="186" actId="14100"/>
         <pc:sldMkLst>
           <pc:docMk/>
           <pc:sldMk cId="4164847936" sldId="256"/>
         </pc:sldMkLst>
         <pc:spChg chg="add mod">
-          <ac:chgData name="Jacques Delort" userId="338bbbaa6367577a" providerId="LiveId" clId="{29EEF4E2-F752-45CC-A7DF-F1AD94B64117}" dt="2026-03-09T08:20:14.944" v="53" actId="1035"/>
+          <ac:chgData name="Jacques Delort" userId="338bbbaa6367577a" providerId="LiveId" clId="{29EEF4E2-F752-45CC-A7DF-F1AD94B64117}" dt="2026-03-12T14:59:00.357" v="172" actId="1076"/>
+          <ac:spMkLst>
+            <pc:docMk/>
+            <pc:sldMk cId="4164847936" sldId="256"/>
+            <ac:spMk id="6" creationId="{30FC81EF-5BD2-CF55-C8A4-1ED90F42C921}"/>
+          </ac:spMkLst>
+        </pc:spChg>
+        <pc:spChg chg="add del mod">
+          <ac:chgData name="Jacques Delort" userId="338bbbaa6367577a" providerId="LiveId" clId="{29EEF4E2-F752-45CC-A7DF-F1AD94B64117}" dt="2026-03-12T14:58:55.097" v="171" actId="478"/>
           <ac:spMkLst>
             <pc:docMk/>
             <pc:sldMk cId="4164847936" sldId="256"/>
@@ -147,7 +155,7 @@
           </ac:spMkLst>
         </pc:spChg>
         <pc:spChg chg="add mod">
-          <ac:chgData name="Jacques Delort" userId="338bbbaa6367577a" providerId="LiveId" clId="{29EEF4E2-F752-45CC-A7DF-F1AD94B64117}" dt="2026-03-09T08:20:07.545" v="52" actId="1037"/>
+          <ac:chgData name="Jacques Delort" userId="338bbbaa6367577a" providerId="LiveId" clId="{29EEF4E2-F752-45CC-A7DF-F1AD94B64117}" dt="2026-03-12T14:59:40.004" v="184" actId="1036"/>
           <ac:spMkLst>
             <pc:docMk/>
             <pc:sldMk cId="4164847936" sldId="256"/>
@@ -155,239 +163,23 @@
           </ac:spMkLst>
         </pc:spChg>
         <pc:spChg chg="add mod">
-          <ac:chgData name="Jacques Delort" userId="338bbbaa6367577a" providerId="LiveId" clId="{29EEF4E2-F752-45CC-A7DF-F1AD94B64117}" dt="2026-03-09T08:20:27.380" v="161" actId="1036"/>
+          <ac:chgData name="Jacques Delort" userId="338bbbaa6367577a" providerId="LiveId" clId="{29EEF4E2-F752-45CC-A7DF-F1AD94B64117}" dt="2026-03-12T14:59:25.786" v="178" actId="1036"/>
           <ac:spMkLst>
             <pc:docMk/>
             <pc:sldMk cId="4164847936" sldId="256"/>
             <ac:spMk id="34" creationId="{9E06503B-7BAA-5B66-D789-ACFF62E81E20}"/>
           </ac:spMkLst>
         </pc:spChg>
-        <pc:grpChg chg="add del mod">
-          <ac:chgData name="Jacques Delort" userId="338bbbaa6367577a" providerId="LiveId" clId="{29EEF4E2-F752-45CC-A7DF-F1AD94B64117}" dt="2026-03-09T08:18:04.713" v="32" actId="478"/>
-          <ac:grpSpMkLst>
-            <pc:docMk/>
-            <pc:sldMk cId="4164847936" sldId="256"/>
-            <ac:grpSpMk id="7" creationId="{E6CC6447-67B7-02BF-4AAB-B1BF92786B69}"/>
-          </ac:grpSpMkLst>
-        </pc:grpChg>
-        <pc:grpChg chg="add del mod">
-          <ac:chgData name="Jacques Delort" userId="338bbbaa6367577a" providerId="LiveId" clId="{29EEF4E2-F752-45CC-A7DF-F1AD94B64117}" dt="2026-03-09T08:18:04.713" v="32" actId="478"/>
-          <ac:grpSpMkLst>
-            <pc:docMk/>
-            <pc:sldMk cId="4164847936" sldId="256"/>
-            <ac:grpSpMk id="8" creationId="{CC49AD1E-E8AC-5EAB-D878-FF2F111BFE88}"/>
-          </ac:grpSpMkLst>
-        </pc:grpChg>
-        <pc:grpChg chg="add del mod">
-          <ac:chgData name="Jacques Delort" userId="338bbbaa6367577a" providerId="LiveId" clId="{29EEF4E2-F752-45CC-A7DF-F1AD94B64117}" dt="2026-03-09T08:18:04.713" v="32" actId="478"/>
-          <ac:grpSpMkLst>
-            <pc:docMk/>
-            <pc:sldMk cId="4164847936" sldId="256"/>
-            <ac:grpSpMk id="12" creationId="{695BDF72-2698-196F-603E-2CB5060ECBE0}"/>
-          </ac:grpSpMkLst>
-        </pc:grpChg>
-        <pc:grpChg chg="add del mod">
-          <ac:chgData name="Jacques Delort" userId="338bbbaa6367577a" providerId="LiveId" clId="{29EEF4E2-F752-45CC-A7DF-F1AD94B64117}" dt="2026-03-09T08:18:04.713" v="32" actId="478"/>
-          <ac:grpSpMkLst>
-            <pc:docMk/>
-            <pc:sldMk cId="4164847936" sldId="256"/>
-            <ac:grpSpMk id="16" creationId="{D7C4DB7E-5010-CA1D-15DE-457832718E75}"/>
-          </ac:grpSpMkLst>
-        </pc:grpChg>
-        <pc:grpChg chg="add del mod">
-          <ac:chgData name="Jacques Delort" userId="338bbbaa6367577a" providerId="LiveId" clId="{29EEF4E2-F752-45CC-A7DF-F1AD94B64117}" dt="2026-03-09T08:18:04.713" v="32" actId="478"/>
-          <ac:grpSpMkLst>
-            <pc:docMk/>
-            <pc:sldMk cId="4164847936" sldId="256"/>
-            <ac:grpSpMk id="20" creationId="{6BA576CB-0E49-F488-7BB0-6CA8B8324917}"/>
-          </ac:grpSpMkLst>
-        </pc:grpChg>
-        <pc:grpChg chg="add del mod">
-          <ac:chgData name="Jacques Delort" userId="338bbbaa6367577a" providerId="LiveId" clId="{29EEF4E2-F752-45CC-A7DF-F1AD94B64117}" dt="2026-03-09T08:18:04.713" v="32" actId="478"/>
-          <ac:grpSpMkLst>
-            <pc:docMk/>
-            <pc:sldMk cId="4164847936" sldId="256"/>
-            <ac:grpSpMk id="24" creationId="{CCC06B75-E64F-23C2-E72A-FFEB0D4FADBE}"/>
-          </ac:grpSpMkLst>
-        </pc:grpChg>
-        <pc:grpChg chg="add del mod">
-          <ac:chgData name="Jacques Delort" userId="338bbbaa6367577a" providerId="LiveId" clId="{29EEF4E2-F752-45CC-A7DF-F1AD94B64117}" dt="2026-03-09T08:18:04.713" v="32" actId="478"/>
-          <ac:grpSpMkLst>
-            <pc:docMk/>
-            <pc:sldMk cId="4164847936" sldId="256"/>
-            <ac:grpSpMk id="28" creationId="{21F12C76-951C-19E7-FC9E-8C6A00FF7A52}"/>
-          </ac:grpSpMkLst>
-        </pc:grpChg>
-        <pc:cxnChg chg="add mod">
-          <ac:chgData name="Jacques Delort" userId="338bbbaa6367577a" providerId="LiveId" clId="{29EEF4E2-F752-45CC-A7DF-F1AD94B64117}" dt="2026-03-09T08:16:19.804" v="11" actId="164"/>
+        <pc:cxnChg chg="add del mod">
+          <ac:chgData name="Jacques Delort" userId="338bbbaa6367577a" providerId="LiveId" clId="{29EEF4E2-F752-45CC-A7DF-F1AD94B64117}" dt="2026-03-12T14:59:05.457" v="173" actId="478"/>
           <ac:cxnSpMkLst>
             <pc:docMk/>
             <pc:sldMk cId="4164847936" sldId="256"/>
-            <ac:cxnSpMk id="3" creationId="{509B9223-4E9D-1682-D265-5A298EB95378}"/>
+            <ac:cxnSpMk id="4" creationId="{98ABC3DA-3309-0A01-5160-80E3D5CE4E3F}"/>
           </ac:cxnSpMkLst>
         </pc:cxnChg>
         <pc:cxnChg chg="add mod">
-          <ac:chgData name="Jacques Delort" userId="338bbbaa6367577a" providerId="LiveId" clId="{29EEF4E2-F752-45CC-A7DF-F1AD94B64117}" dt="2026-03-09T08:16:19.804" v="11" actId="164"/>
-          <ac:cxnSpMkLst>
-            <pc:docMk/>
-            <pc:sldMk cId="4164847936" sldId="256"/>
-            <ac:cxnSpMk id="4" creationId="{65408C89-C011-4059-C38F-9B3E066F269E}"/>
-          </ac:cxnSpMkLst>
-        </pc:cxnChg>
-        <pc:cxnChg chg="add mod">
-          <ac:chgData name="Jacques Delort" userId="338bbbaa6367577a" providerId="LiveId" clId="{29EEF4E2-F752-45CC-A7DF-F1AD94B64117}" dt="2026-03-09T08:16:19.804" v="11" actId="164"/>
-          <ac:cxnSpMkLst>
-            <pc:docMk/>
-            <pc:sldMk cId="4164847936" sldId="256"/>
-            <ac:cxnSpMk id="6" creationId="{D9ACE838-7097-5493-1326-C2BB1FBB9D58}"/>
-          </ac:cxnSpMkLst>
-        </pc:cxnChg>
-        <pc:cxnChg chg="mod">
-          <ac:chgData name="Jacques Delort" userId="338bbbaa6367577a" providerId="LiveId" clId="{29EEF4E2-F752-45CC-A7DF-F1AD94B64117}" dt="2026-03-09T08:16:24.951" v="13"/>
-          <ac:cxnSpMkLst>
-            <pc:docMk/>
-            <pc:sldMk cId="4164847936" sldId="256"/>
-            <ac:cxnSpMk id="9" creationId="{3662788E-BF38-B14D-1659-F38C8779C7D6}"/>
-          </ac:cxnSpMkLst>
-        </pc:cxnChg>
-        <pc:cxnChg chg="mod">
-          <ac:chgData name="Jacques Delort" userId="338bbbaa6367577a" providerId="LiveId" clId="{29EEF4E2-F752-45CC-A7DF-F1AD94B64117}" dt="2026-03-09T08:16:24.951" v="13"/>
-          <ac:cxnSpMkLst>
-            <pc:docMk/>
-            <pc:sldMk cId="4164847936" sldId="256"/>
-            <ac:cxnSpMk id="10" creationId="{CA0AF580-E15B-4768-7D1E-F6298334A394}"/>
-          </ac:cxnSpMkLst>
-        </pc:cxnChg>
-        <pc:cxnChg chg="mod">
-          <ac:chgData name="Jacques Delort" userId="338bbbaa6367577a" providerId="LiveId" clId="{29EEF4E2-F752-45CC-A7DF-F1AD94B64117}" dt="2026-03-09T08:16:24.951" v="13"/>
-          <ac:cxnSpMkLst>
-            <pc:docMk/>
-            <pc:sldMk cId="4164847936" sldId="256"/>
-            <ac:cxnSpMk id="11" creationId="{8BE40ECC-7A6F-DA26-2BC7-408DF0F28F1A}"/>
-          </ac:cxnSpMkLst>
-        </pc:cxnChg>
-        <pc:cxnChg chg="mod">
-          <ac:chgData name="Jacques Delort" userId="338bbbaa6367577a" providerId="LiveId" clId="{29EEF4E2-F752-45CC-A7DF-F1AD94B64117}" dt="2026-03-09T08:17:09.833" v="20"/>
-          <ac:cxnSpMkLst>
-            <pc:docMk/>
-            <pc:sldMk cId="4164847936" sldId="256"/>
-            <ac:cxnSpMk id="13" creationId="{8AADBE31-B817-F9B7-BFA8-25EF796687B6}"/>
-          </ac:cxnSpMkLst>
-        </pc:cxnChg>
-        <pc:cxnChg chg="mod">
-          <ac:chgData name="Jacques Delort" userId="338bbbaa6367577a" providerId="LiveId" clId="{29EEF4E2-F752-45CC-A7DF-F1AD94B64117}" dt="2026-03-09T08:17:09.833" v="20"/>
-          <ac:cxnSpMkLst>
-            <pc:docMk/>
-            <pc:sldMk cId="4164847936" sldId="256"/>
-            <ac:cxnSpMk id="14" creationId="{FE1DD088-2794-7495-1F41-C89C3DF265EE}"/>
-          </ac:cxnSpMkLst>
-        </pc:cxnChg>
-        <pc:cxnChg chg="mod">
-          <ac:chgData name="Jacques Delort" userId="338bbbaa6367577a" providerId="LiveId" clId="{29EEF4E2-F752-45CC-A7DF-F1AD94B64117}" dt="2026-03-09T08:17:09.833" v="20"/>
-          <ac:cxnSpMkLst>
-            <pc:docMk/>
-            <pc:sldMk cId="4164847936" sldId="256"/>
-            <ac:cxnSpMk id="15" creationId="{C6AFFC3C-FD8D-302E-1880-91CAC724FA6F}"/>
-          </ac:cxnSpMkLst>
-        </pc:cxnChg>
-        <pc:cxnChg chg="mod">
-          <ac:chgData name="Jacques Delort" userId="338bbbaa6367577a" providerId="LiveId" clId="{29EEF4E2-F752-45CC-A7DF-F1AD94B64117}" dt="2026-03-09T08:17:15.432" v="22"/>
-          <ac:cxnSpMkLst>
-            <pc:docMk/>
-            <pc:sldMk cId="4164847936" sldId="256"/>
-            <ac:cxnSpMk id="17" creationId="{3A365BE7-F415-FF95-DE21-279DAA4FFE79}"/>
-          </ac:cxnSpMkLst>
-        </pc:cxnChg>
-        <pc:cxnChg chg="mod">
-          <ac:chgData name="Jacques Delort" userId="338bbbaa6367577a" providerId="LiveId" clId="{29EEF4E2-F752-45CC-A7DF-F1AD94B64117}" dt="2026-03-09T08:17:15.432" v="22"/>
-          <ac:cxnSpMkLst>
-            <pc:docMk/>
-            <pc:sldMk cId="4164847936" sldId="256"/>
-            <ac:cxnSpMk id="18" creationId="{CE654C14-AE20-BD4A-A558-6A4832010BA3}"/>
-          </ac:cxnSpMkLst>
-        </pc:cxnChg>
-        <pc:cxnChg chg="mod">
-          <ac:chgData name="Jacques Delort" userId="338bbbaa6367577a" providerId="LiveId" clId="{29EEF4E2-F752-45CC-A7DF-F1AD94B64117}" dt="2026-03-09T08:17:15.432" v="22"/>
-          <ac:cxnSpMkLst>
-            <pc:docMk/>
-            <pc:sldMk cId="4164847936" sldId="256"/>
-            <ac:cxnSpMk id="19" creationId="{4F7E4D2A-1B3E-FF22-73D8-AF42AADB2F15}"/>
-          </ac:cxnSpMkLst>
-        </pc:cxnChg>
-        <pc:cxnChg chg="mod">
-          <ac:chgData name="Jacques Delort" userId="338bbbaa6367577a" providerId="LiveId" clId="{29EEF4E2-F752-45CC-A7DF-F1AD94B64117}" dt="2026-03-09T08:17:24.886" v="25"/>
-          <ac:cxnSpMkLst>
-            <pc:docMk/>
-            <pc:sldMk cId="4164847936" sldId="256"/>
-            <ac:cxnSpMk id="21" creationId="{FD959FC8-F556-C012-6A13-389012174D46}"/>
-          </ac:cxnSpMkLst>
-        </pc:cxnChg>
-        <pc:cxnChg chg="mod">
-          <ac:chgData name="Jacques Delort" userId="338bbbaa6367577a" providerId="LiveId" clId="{29EEF4E2-F752-45CC-A7DF-F1AD94B64117}" dt="2026-03-09T08:17:24.886" v="25"/>
-          <ac:cxnSpMkLst>
-            <pc:docMk/>
-            <pc:sldMk cId="4164847936" sldId="256"/>
-            <ac:cxnSpMk id="22" creationId="{84EF3B4A-72DD-2038-37DE-574BFDAB6345}"/>
-          </ac:cxnSpMkLst>
-        </pc:cxnChg>
-        <pc:cxnChg chg="mod">
-          <ac:chgData name="Jacques Delort" userId="338bbbaa6367577a" providerId="LiveId" clId="{29EEF4E2-F752-45CC-A7DF-F1AD94B64117}" dt="2026-03-09T08:17:24.886" v="25"/>
-          <ac:cxnSpMkLst>
-            <pc:docMk/>
-            <pc:sldMk cId="4164847936" sldId="256"/>
-            <ac:cxnSpMk id="23" creationId="{81632275-B2A5-A327-E8CE-E707568984B4}"/>
-          </ac:cxnSpMkLst>
-        </pc:cxnChg>
-        <pc:cxnChg chg="mod">
-          <ac:chgData name="Jacques Delort" userId="338bbbaa6367577a" providerId="LiveId" clId="{29EEF4E2-F752-45CC-A7DF-F1AD94B64117}" dt="2026-03-09T08:17:30.709" v="27"/>
-          <ac:cxnSpMkLst>
-            <pc:docMk/>
-            <pc:sldMk cId="4164847936" sldId="256"/>
-            <ac:cxnSpMk id="25" creationId="{038F644C-963D-FB8F-6D3D-BADFEE0EEA74}"/>
-          </ac:cxnSpMkLst>
-        </pc:cxnChg>
-        <pc:cxnChg chg="mod">
-          <ac:chgData name="Jacques Delort" userId="338bbbaa6367577a" providerId="LiveId" clId="{29EEF4E2-F752-45CC-A7DF-F1AD94B64117}" dt="2026-03-09T08:17:30.709" v="27"/>
-          <ac:cxnSpMkLst>
-            <pc:docMk/>
-            <pc:sldMk cId="4164847936" sldId="256"/>
-            <ac:cxnSpMk id="26" creationId="{463E8FD3-EF1B-2755-2324-26CDE0EA9BD9}"/>
-          </ac:cxnSpMkLst>
-        </pc:cxnChg>
-        <pc:cxnChg chg="mod">
-          <ac:chgData name="Jacques Delort" userId="338bbbaa6367577a" providerId="LiveId" clId="{29EEF4E2-F752-45CC-A7DF-F1AD94B64117}" dt="2026-03-09T08:17:30.709" v="27"/>
-          <ac:cxnSpMkLst>
-            <pc:docMk/>
-            <pc:sldMk cId="4164847936" sldId="256"/>
-            <ac:cxnSpMk id="27" creationId="{70D37497-60F1-B9D7-8F3F-26651AE05F39}"/>
-          </ac:cxnSpMkLst>
-        </pc:cxnChg>
-        <pc:cxnChg chg="mod">
-          <ac:chgData name="Jacques Delort" userId="338bbbaa6367577a" providerId="LiveId" clId="{29EEF4E2-F752-45CC-A7DF-F1AD94B64117}" dt="2026-03-09T08:17:39.202" v="29"/>
-          <ac:cxnSpMkLst>
-            <pc:docMk/>
-            <pc:sldMk cId="4164847936" sldId="256"/>
-            <ac:cxnSpMk id="29" creationId="{9B170877-3C32-234E-8601-D30476C33E66}"/>
-          </ac:cxnSpMkLst>
-        </pc:cxnChg>
-        <pc:cxnChg chg="mod">
-          <ac:chgData name="Jacques Delort" userId="338bbbaa6367577a" providerId="LiveId" clId="{29EEF4E2-F752-45CC-A7DF-F1AD94B64117}" dt="2026-03-09T08:17:39.202" v="29"/>
-          <ac:cxnSpMkLst>
-            <pc:docMk/>
-            <pc:sldMk cId="4164847936" sldId="256"/>
-            <ac:cxnSpMk id="30" creationId="{A0D5D03E-27E1-2642-0C0F-AA3A29BEA349}"/>
-          </ac:cxnSpMkLst>
-        </pc:cxnChg>
-        <pc:cxnChg chg="mod">
-          <ac:chgData name="Jacques Delort" userId="338bbbaa6367577a" providerId="LiveId" clId="{29EEF4E2-F752-45CC-A7DF-F1AD94B64117}" dt="2026-03-09T08:17:39.202" v="29"/>
-          <ac:cxnSpMkLst>
-            <pc:docMk/>
-            <pc:sldMk cId="4164847936" sldId="256"/>
-            <ac:cxnSpMk id="31" creationId="{0D9DD1FE-FE49-CA8B-B720-B9C9FCD0082A}"/>
-          </ac:cxnSpMkLst>
-        </pc:cxnChg>
-        <pc:cxnChg chg="add mod">
-          <ac:chgData name="Jacques Delort" userId="338bbbaa6367577a" providerId="LiveId" clId="{29EEF4E2-F752-45CC-A7DF-F1AD94B64117}" dt="2026-03-09T08:22:34.040" v="163" actId="13822"/>
+          <ac:chgData name="Jacques Delort" userId="338bbbaa6367577a" providerId="LiveId" clId="{29EEF4E2-F752-45CC-A7DF-F1AD94B64117}" dt="2026-03-12T14:59:48.166" v="186" actId="14100"/>
           <ac:cxnSpMkLst>
             <pc:docMk/>
             <pc:sldMk cId="4164847936" sldId="256"/>
@@ -482,7 +274,7 @@
           <a:p>
             <a:fld id="{1FCC755A-E4A9-472B-9F9E-A9F73C19AD1B}" type="datetimeFigureOut">
               <a:rPr lang="fr-FR" smtClean="0"/>
-              <a:t>09/03/2026</a:t>
+              <a:t>12/03/2026</a:t>
             </a:fld>
             <a:endParaRPr lang="fr-FR"/>
           </a:p>
@@ -980,7 +772,7 @@
           <a:p>
             <a:fld id="{FDD8E558-C07A-436E-9726-A2B3122036E2}" type="datetimeFigureOut">
               <a:rPr lang="fr-FR" smtClean="0"/>
-              <a:t>09/03/2026</a:t>
+              <a:t>12/03/2026</a:t>
             </a:fld>
             <a:endParaRPr lang="fr-FR"/>
           </a:p>
@@ -1178,7 +970,7 @@
           <a:p>
             <a:fld id="{FDD8E558-C07A-436E-9726-A2B3122036E2}" type="datetimeFigureOut">
               <a:rPr lang="fr-FR" smtClean="0"/>
-              <a:t>09/03/2026</a:t>
+              <a:t>12/03/2026</a:t>
             </a:fld>
             <a:endParaRPr lang="fr-FR"/>
           </a:p>
@@ -1386,7 +1178,7 @@
           <a:p>
             <a:fld id="{FDD8E558-C07A-436E-9726-A2B3122036E2}" type="datetimeFigureOut">
               <a:rPr lang="fr-FR" smtClean="0"/>
-              <a:t>09/03/2026</a:t>
+              <a:t>12/03/2026</a:t>
             </a:fld>
             <a:endParaRPr lang="fr-FR"/>
           </a:p>
@@ -1584,7 +1376,7 @@
           <a:p>
             <a:fld id="{FDD8E558-C07A-436E-9726-A2B3122036E2}" type="datetimeFigureOut">
               <a:rPr lang="fr-FR" smtClean="0"/>
-              <a:t>09/03/2026</a:t>
+              <a:t>12/03/2026</a:t>
             </a:fld>
             <a:endParaRPr lang="fr-FR"/>
           </a:p>
@@ -1859,7 +1651,7 @@
           <a:p>
             <a:fld id="{FDD8E558-C07A-436E-9726-A2B3122036E2}" type="datetimeFigureOut">
               <a:rPr lang="fr-FR" smtClean="0"/>
-              <a:t>09/03/2026</a:t>
+              <a:t>12/03/2026</a:t>
             </a:fld>
             <a:endParaRPr lang="fr-FR"/>
           </a:p>
@@ -2124,7 +1916,7 @@
           <a:p>
             <a:fld id="{FDD8E558-C07A-436E-9726-A2B3122036E2}" type="datetimeFigureOut">
               <a:rPr lang="fr-FR" smtClean="0"/>
-              <a:t>09/03/2026</a:t>
+              <a:t>12/03/2026</a:t>
             </a:fld>
             <a:endParaRPr lang="fr-FR"/>
           </a:p>
@@ -2536,7 +2328,7 @@
           <a:p>
             <a:fld id="{FDD8E558-C07A-436E-9726-A2B3122036E2}" type="datetimeFigureOut">
               <a:rPr lang="fr-FR" smtClean="0"/>
-              <a:t>09/03/2026</a:t>
+              <a:t>12/03/2026</a:t>
             </a:fld>
             <a:endParaRPr lang="fr-FR"/>
           </a:p>
@@ -2677,7 +2469,7 @@
           <a:p>
             <a:fld id="{FDD8E558-C07A-436E-9726-A2B3122036E2}" type="datetimeFigureOut">
               <a:rPr lang="fr-FR" smtClean="0"/>
-              <a:t>09/03/2026</a:t>
+              <a:t>12/03/2026</a:t>
             </a:fld>
             <a:endParaRPr lang="fr-FR"/>
           </a:p>
@@ -2790,7 +2582,7 @@
           <a:p>
             <a:fld id="{FDD8E558-C07A-436E-9726-A2B3122036E2}" type="datetimeFigureOut">
               <a:rPr lang="fr-FR" smtClean="0"/>
-              <a:t>09/03/2026</a:t>
+              <a:t>12/03/2026</a:t>
             </a:fld>
             <a:endParaRPr lang="fr-FR"/>
           </a:p>
@@ -3101,7 +2893,7 @@
           <a:p>
             <a:fld id="{FDD8E558-C07A-436E-9726-A2B3122036E2}" type="datetimeFigureOut">
               <a:rPr lang="fr-FR" smtClean="0"/>
-              <a:t>09/03/2026</a:t>
+              <a:t>12/03/2026</a:t>
             </a:fld>
             <a:endParaRPr lang="fr-FR"/>
           </a:p>
@@ -3389,7 +3181,7 @@
           <a:p>
             <a:fld id="{FDD8E558-C07A-436E-9726-A2B3122036E2}" type="datetimeFigureOut">
               <a:rPr lang="fr-FR" smtClean="0"/>
-              <a:t>09/03/2026</a:t>
+              <a:t>12/03/2026</a:t>
             </a:fld>
             <a:endParaRPr lang="fr-FR"/>
           </a:p>
@@ -3630,7 +3422,7 @@
           <a:p>
             <a:fld id="{FDD8E558-C07A-436E-9726-A2B3122036E2}" type="datetimeFigureOut">
               <a:rPr lang="fr-FR" smtClean="0"/>
-              <a:t>09/03/2026</a:t>
+              <a:t>12/03/2026</a:t>
             </a:fld>
             <a:endParaRPr lang="fr-FR"/>
           </a:p>
@@ -4049,10 +3841,10 @@
       </p:grpSpPr>
       <p:sp>
         <p:nvSpPr>
-          <p:cNvPr id="32" name="Forme libre : forme 31">
-            <a:extLst>
-              <a:ext uri="{FF2B5EF4-FFF2-40B4-BE49-F238E27FC236}">
-                <a16:creationId xmlns:a16="http://schemas.microsoft.com/office/drawing/2014/main" id="{3B80BEB3-5FBB-9BC6-EEB8-F0E55FDCD194}"/>
+          <p:cNvPr id="33" name="Ellipse 32">
+            <a:extLst>
+              <a:ext uri="{FF2B5EF4-FFF2-40B4-BE49-F238E27FC236}">
+                <a16:creationId xmlns:a16="http://schemas.microsoft.com/office/drawing/2014/main" id="{14BE3A2E-4596-6897-D01D-7A80132AB997}"/>
               </a:ext>
             </a:extLst>
           </p:cNvPr>
@@ -4061,32 +3853,172 @@
         </p:nvSpPr>
         <p:spPr>
           <a:xfrm>
-            <a:off x="1037690" y="2204864"/>
-            <a:ext cx="6318607" cy="2352782"/>
+            <a:off x="983432" y="3284984"/>
+            <a:ext cx="72008" cy="72008"/>
+          </a:xfrm>
+          <a:prstGeom prst="ellipse">
+            <a:avLst/>
+          </a:prstGeom>
+        </p:spPr>
+        <p:style>
+          <a:lnRef idx="2">
+            <a:schemeClr val="accent2">
+              <a:shade val="15000"/>
+            </a:schemeClr>
+          </a:lnRef>
+          <a:fillRef idx="1">
+            <a:schemeClr val="accent2"/>
+          </a:fillRef>
+          <a:effectRef idx="0">
+            <a:schemeClr val="accent2"/>
+          </a:effectRef>
+          <a:fontRef idx="minor">
+            <a:schemeClr val="lt1"/>
+          </a:fontRef>
+        </p:style>
+        <p:txBody>
+          <a:bodyPr rtlCol="0" anchor="ctr"/>
+          <a:lstStyle/>
+          <a:p>
+            <a:pPr algn="ctr"/>
+            <a:endParaRPr lang="fr-FR"/>
+          </a:p>
+        </p:txBody>
+      </p:sp>
+      <p:sp>
+        <p:nvSpPr>
+          <p:cNvPr id="34" name="Ellipse 33">
+            <a:extLst>
+              <a:ext uri="{FF2B5EF4-FFF2-40B4-BE49-F238E27FC236}">
+                <a16:creationId xmlns:a16="http://schemas.microsoft.com/office/drawing/2014/main" id="{9E06503B-7BAA-5B66-D789-ACFF62E81E20}"/>
+              </a:ext>
+            </a:extLst>
+          </p:cNvPr>
+          <p:cNvSpPr/>
+          <p:nvPr/>
+        </p:nvSpPr>
+        <p:spPr>
+          <a:xfrm>
+            <a:off x="8482809" y="5373216"/>
+            <a:ext cx="72008" cy="72008"/>
+          </a:xfrm>
+          <a:prstGeom prst="ellipse">
+            <a:avLst/>
+          </a:prstGeom>
+        </p:spPr>
+        <p:style>
+          <a:lnRef idx="2">
+            <a:schemeClr val="accent2">
+              <a:shade val="15000"/>
+            </a:schemeClr>
+          </a:lnRef>
+          <a:fillRef idx="1">
+            <a:schemeClr val="accent2"/>
+          </a:fillRef>
+          <a:effectRef idx="0">
+            <a:schemeClr val="accent2"/>
+          </a:effectRef>
+          <a:fontRef idx="minor">
+            <a:schemeClr val="lt1"/>
+          </a:fontRef>
+        </p:style>
+        <p:txBody>
+          <a:bodyPr rtlCol="0" anchor="ctr"/>
+          <a:lstStyle/>
+          <a:p>
+            <a:pPr algn="ctr"/>
+            <a:endParaRPr lang="fr-FR"/>
+          </a:p>
+        </p:txBody>
+      </p:sp>
+      <p:cxnSp>
+        <p:nvCxnSpPr>
+          <p:cNvPr id="36" name="Connecteur droit 35">
+            <a:extLst>
+              <a:ext uri="{FF2B5EF4-FFF2-40B4-BE49-F238E27FC236}">
+                <a16:creationId xmlns:a16="http://schemas.microsoft.com/office/drawing/2014/main" id="{2B433686-D63C-2008-0A5F-CCAD2C826A5A}"/>
+              </a:ext>
+            </a:extLst>
+          </p:cNvPr>
+          <p:cNvCxnSpPr>
+            <a:cxnSpLocks/>
+            <a:stCxn id="33" idx="5"/>
+            <a:endCxn id="34" idx="2"/>
+          </p:cNvCxnSpPr>
+          <p:nvPr/>
+        </p:nvCxnSpPr>
+        <p:spPr>
+          <a:xfrm>
+            <a:off x="1044895" y="3346447"/>
+            <a:ext cx="7437914" cy="2062773"/>
+          </a:xfrm>
+          <a:prstGeom prst="line">
+            <a:avLst/>
+          </a:prstGeom>
+        </p:spPr>
+        <p:style>
+          <a:lnRef idx="2">
+            <a:schemeClr val="accent2"/>
+          </a:lnRef>
+          <a:fillRef idx="0">
+            <a:schemeClr val="accent2"/>
+          </a:fillRef>
+          <a:effectRef idx="1">
+            <a:schemeClr val="accent2"/>
+          </a:effectRef>
+          <a:fontRef idx="minor">
+            <a:schemeClr val="tx1"/>
+          </a:fontRef>
+        </p:style>
+      </p:cxnSp>
+      <p:sp>
+        <p:nvSpPr>
+          <p:cNvPr id="6" name="Forme libre : forme 5">
+            <a:extLst>
+              <a:ext uri="{FF2B5EF4-FFF2-40B4-BE49-F238E27FC236}">
+                <a16:creationId xmlns:a16="http://schemas.microsoft.com/office/drawing/2014/main" id="{30FC81EF-5BD2-CF55-C8A4-1ED90F42C921}"/>
+              </a:ext>
+            </a:extLst>
+          </p:cNvPr>
+          <p:cNvSpPr/>
+          <p:nvPr/>
+        </p:nvSpPr>
+        <p:spPr>
+          <a:xfrm>
+            <a:off x="1019436" y="2383174"/>
+            <a:ext cx="6996702" cy="2568539"/>
           </a:xfrm>
           <a:custGeom>
             <a:avLst/>
             <a:gdLst>
-              <a:gd name="csX0" fmla="*/ 0 w 6318607"/>
-              <a:gd name="csY0" fmla="*/ 1027415 h 2352782"/>
-              <a:gd name="csX1" fmla="*/ 750013 w 6318607"/>
-              <a:gd name="csY1" fmla="*/ 575352 h 2352782"/>
-              <a:gd name="csX2" fmla="*/ 1222625 w 6318607"/>
-              <a:gd name="csY2" fmla="*/ 811658 h 2352782"/>
-              <a:gd name="csX3" fmla="*/ 1849348 w 6318607"/>
-              <a:gd name="csY3" fmla="*/ 297950 h 2352782"/>
-              <a:gd name="csX4" fmla="*/ 2743200 w 6318607"/>
-              <a:gd name="csY4" fmla="*/ 0 h 2352782"/>
-              <a:gd name="csX5" fmla="*/ 4109663 w 6318607"/>
-              <a:gd name="csY5" fmla="*/ 61645 h 2352782"/>
-              <a:gd name="csX6" fmla="*/ 5383658 w 6318607"/>
-              <a:gd name="csY6" fmla="*/ 667820 h 2352782"/>
-              <a:gd name="csX7" fmla="*/ 5578867 w 6318607"/>
-              <a:gd name="csY7" fmla="*/ 1140431 h 2352782"/>
-              <a:gd name="csX8" fmla="*/ 6072027 w 6318607"/>
-              <a:gd name="csY8" fmla="*/ 1695236 h 2352782"/>
-              <a:gd name="csX9" fmla="*/ 6318607 w 6318607"/>
-              <a:gd name="csY9" fmla="*/ 2352782 h 2352782"/>
+              <a:gd name="csX0" fmla="*/ 0 w 6996702"/>
+              <a:gd name="csY0" fmla="*/ 904126 h 2568539"/>
+              <a:gd name="csX1" fmla="*/ 267129 w 6996702"/>
+              <a:gd name="csY1" fmla="*/ 349321 h 2568539"/>
+              <a:gd name="csX2" fmla="*/ 729466 w 6996702"/>
+              <a:gd name="csY2" fmla="*/ 791110 h 2568539"/>
+              <a:gd name="csX3" fmla="*/ 688369 w 6996702"/>
+              <a:gd name="csY3" fmla="*/ 164386 h 2568539"/>
+              <a:gd name="csX4" fmla="*/ 1109609 w 6996702"/>
+              <a:gd name="csY4" fmla="*/ 832206 h 2568539"/>
+              <a:gd name="csX5" fmla="*/ 1181529 w 6996702"/>
+              <a:gd name="csY5" fmla="*/ 174660 h 2568539"/>
+              <a:gd name="csX6" fmla="*/ 1571946 w 6996702"/>
+              <a:gd name="csY6" fmla="*/ 688368 h 2568539"/>
+              <a:gd name="csX7" fmla="*/ 1993187 w 6996702"/>
+              <a:gd name="csY7" fmla="*/ 61645 h 2568539"/>
+              <a:gd name="csX8" fmla="*/ 3328827 w 6996702"/>
+              <a:gd name="csY8" fmla="*/ 0 h 2568539"/>
+              <a:gd name="csX9" fmla="*/ 4335695 w 6996702"/>
+              <a:gd name="csY9" fmla="*/ 195209 h 2568539"/>
+              <a:gd name="csX10" fmla="*/ 5599416 w 6996702"/>
+              <a:gd name="csY10" fmla="*/ 431514 h 2568539"/>
+              <a:gd name="csX11" fmla="*/ 5948737 w 6996702"/>
+              <a:gd name="csY11" fmla="*/ 1325366 h 2568539"/>
+              <a:gd name="csX12" fmla="*/ 6359704 w 6996702"/>
+              <a:gd name="csY12" fmla="*/ 2157573 h 2568539"/>
+              <a:gd name="csX13" fmla="*/ 6996702 w 6996702"/>
+              <a:gd name="csY13" fmla="*/ 2568539 h 2568539"/>
             </a:gdLst>
             <a:ahLst/>
             <a:cxnLst>
@@ -4120,39 +4052,63 @@
               <a:cxn ang="0">
                 <a:pos x="csX9" y="csY9"/>
               </a:cxn>
+              <a:cxn ang="0">
+                <a:pos x="csX10" y="csY10"/>
+              </a:cxn>
+              <a:cxn ang="0">
+                <a:pos x="csX11" y="csY11"/>
+              </a:cxn>
+              <a:cxn ang="0">
+                <a:pos x="csX12" y="csY12"/>
+              </a:cxn>
+              <a:cxn ang="0">
+                <a:pos x="csX13" y="csY13"/>
+              </a:cxn>
             </a:cxnLst>
             <a:rect l="l" t="t" r="r" b="b"/>
             <a:pathLst>
-              <a:path w="6318607" h="2352782">
+              <a:path w="6996702" h="2568539">
                 <a:moveTo>
-                  <a:pt x="0" y="1027415"/>
+                  <a:pt x="0" y="904126"/>
                 </a:moveTo>
                 <a:lnTo>
-                  <a:pt x="750013" y="575352"/>
+                  <a:pt x="267129" y="349321"/>
                 </a:lnTo>
                 <a:lnTo>
-                  <a:pt x="1222625" y="811658"/>
+                  <a:pt x="729466" y="791110"/>
                 </a:lnTo>
                 <a:lnTo>
-                  <a:pt x="1849348" y="297950"/>
+                  <a:pt x="688369" y="164386"/>
                 </a:lnTo>
                 <a:lnTo>
-                  <a:pt x="2743200" y="0"/>
+                  <a:pt x="1109609" y="832206"/>
                 </a:lnTo>
                 <a:lnTo>
-                  <a:pt x="4109663" y="61645"/>
+                  <a:pt x="1181529" y="174660"/>
                 </a:lnTo>
                 <a:lnTo>
-                  <a:pt x="5383658" y="667820"/>
+                  <a:pt x="1571946" y="688368"/>
                 </a:lnTo>
                 <a:lnTo>
-                  <a:pt x="5578867" y="1140431"/>
+                  <a:pt x="1993187" y="61645"/>
                 </a:lnTo>
                 <a:lnTo>
-                  <a:pt x="6072027" y="1695236"/>
+                  <a:pt x="3328827" y="0"/>
                 </a:lnTo>
                 <a:lnTo>
-                  <a:pt x="6318607" y="2352782"/>
+                  <a:pt x="4335695" y="195209"/>
+                </a:lnTo>
+                <a:lnTo>
+                  <a:pt x="5599416" y="431514"/>
+                </a:lnTo>
+                <a:lnTo>
+                  <a:pt x="5948737" y="1325366"/>
+                </a:lnTo>
+                <a:lnTo>
+                  <a:pt x="6359704" y="2157573"/>
+                </a:lnTo>
+                <a:lnTo>
+                  <a:pt x="6996702" y="2568539"/>
                 </a:lnTo>
               </a:path>
             </a:pathLst>
@@ -4184,137 +4140,6 @@
           </a:p>
         </p:txBody>
       </p:sp>
-      <p:sp>
-        <p:nvSpPr>
-          <p:cNvPr id="33" name="Ellipse 32">
-            <a:extLst>
-              <a:ext uri="{FF2B5EF4-FFF2-40B4-BE49-F238E27FC236}">
-                <a16:creationId xmlns:a16="http://schemas.microsoft.com/office/drawing/2014/main" id="{14BE3A2E-4596-6897-D01D-7A80132AB997}"/>
-              </a:ext>
-            </a:extLst>
-          </p:cNvPr>
-          <p:cNvSpPr/>
-          <p:nvPr/>
-        </p:nvSpPr>
-        <p:spPr>
-          <a:xfrm>
-            <a:off x="983432" y="3212976"/>
-            <a:ext cx="72008" cy="72008"/>
-          </a:xfrm>
-          <a:prstGeom prst="ellipse">
-            <a:avLst/>
-          </a:prstGeom>
-        </p:spPr>
-        <p:style>
-          <a:lnRef idx="2">
-            <a:schemeClr val="accent2">
-              <a:shade val="15000"/>
-            </a:schemeClr>
-          </a:lnRef>
-          <a:fillRef idx="1">
-            <a:schemeClr val="accent2"/>
-          </a:fillRef>
-          <a:effectRef idx="0">
-            <a:schemeClr val="accent2"/>
-          </a:effectRef>
-          <a:fontRef idx="minor">
-            <a:schemeClr val="lt1"/>
-          </a:fontRef>
-        </p:style>
-        <p:txBody>
-          <a:bodyPr rtlCol="0" anchor="ctr"/>
-          <a:lstStyle/>
-          <a:p>
-            <a:pPr algn="ctr"/>
-            <a:endParaRPr lang="fr-FR"/>
-          </a:p>
-        </p:txBody>
-      </p:sp>
-      <p:sp>
-        <p:nvSpPr>
-          <p:cNvPr id="34" name="Ellipse 33">
-            <a:extLst>
-              <a:ext uri="{FF2B5EF4-FFF2-40B4-BE49-F238E27FC236}">
-                <a16:creationId xmlns:a16="http://schemas.microsoft.com/office/drawing/2014/main" id="{9E06503B-7BAA-5B66-D789-ACFF62E81E20}"/>
-              </a:ext>
-            </a:extLst>
-          </p:cNvPr>
-          <p:cNvSpPr/>
-          <p:nvPr/>
-        </p:nvSpPr>
-        <p:spPr>
-          <a:xfrm>
-            <a:off x="7536160" y="4653136"/>
-            <a:ext cx="72008" cy="72008"/>
-          </a:xfrm>
-          <a:prstGeom prst="ellipse">
-            <a:avLst/>
-          </a:prstGeom>
-        </p:spPr>
-        <p:style>
-          <a:lnRef idx="2">
-            <a:schemeClr val="accent2">
-              <a:shade val="15000"/>
-            </a:schemeClr>
-          </a:lnRef>
-          <a:fillRef idx="1">
-            <a:schemeClr val="accent2"/>
-          </a:fillRef>
-          <a:effectRef idx="0">
-            <a:schemeClr val="accent2"/>
-          </a:effectRef>
-          <a:fontRef idx="minor">
-            <a:schemeClr val="lt1"/>
-          </a:fontRef>
-        </p:style>
-        <p:txBody>
-          <a:bodyPr rtlCol="0" anchor="ctr"/>
-          <a:lstStyle/>
-          <a:p>
-            <a:pPr algn="ctr"/>
-            <a:endParaRPr lang="fr-FR"/>
-          </a:p>
-        </p:txBody>
-      </p:sp>
-      <p:cxnSp>
-        <p:nvCxnSpPr>
-          <p:cNvPr id="36" name="Connecteur droit 35">
-            <a:extLst>
-              <a:ext uri="{FF2B5EF4-FFF2-40B4-BE49-F238E27FC236}">
-                <a16:creationId xmlns:a16="http://schemas.microsoft.com/office/drawing/2014/main" id="{2B433686-D63C-2008-0A5F-CCAD2C826A5A}"/>
-              </a:ext>
-            </a:extLst>
-          </p:cNvPr>
-          <p:cNvCxnSpPr>
-            <a:stCxn id="33" idx="5"/>
-            <a:endCxn id="34" idx="6"/>
-          </p:cNvCxnSpPr>
-          <p:nvPr/>
-        </p:nvCxnSpPr>
-        <p:spPr>
-          <a:xfrm>
-            <a:off x="1044895" y="3274439"/>
-            <a:ext cx="6491265" cy="1414701"/>
-          </a:xfrm>
-          <a:prstGeom prst="line">
-            <a:avLst/>
-          </a:prstGeom>
-        </p:spPr>
-        <p:style>
-          <a:lnRef idx="2">
-            <a:schemeClr val="accent2"/>
-          </a:lnRef>
-          <a:fillRef idx="0">
-            <a:schemeClr val="accent2"/>
-          </a:fillRef>
-          <a:effectRef idx="1">
-            <a:schemeClr val="accent2"/>
-          </a:effectRef>
-          <a:fontRef idx="minor">
-            <a:schemeClr val="tx1"/>
-          </a:fontRef>
-        </p:style>
-      </p:cxnSp>
     </p:spTree>
     <p:extLst>
       <p:ext uri="{BB962C8B-B14F-4D97-AF65-F5344CB8AC3E}">

</xml_diff>

<commit_message>
Optimisation de la méthode _normalize_cable_geometry avec des améliorations supplémentaires pour la gestion des segments et des contraintes. Mise à jour des tests pour inclure des cas de normalisation supplémentaires et renforcement des assertions pour garantir la conformité aux spécifications de longueur.
</commit_message>
<xml_diff>
--- a/simulateur_rov/Ordres de grandeur.pptx
+++ b/simulateur_rov/Ordres de grandeur.pptx
@@ -5,10 +5,11 @@
     <p:sldMasterId id="2147483648" r:id="rId1"/>
   </p:sldMasterIdLst>
   <p:notesMasterIdLst>
-    <p:notesMasterId r:id="rId3"/>
+    <p:notesMasterId r:id="rId4"/>
   </p:notesMasterIdLst>
   <p:sldIdLst>
     <p:sldId id="256" r:id="rId2"/>
+    <p:sldId id="257" r:id="rId3"/>
   </p:sldIdLst>
   <p:sldSz cx="12192000" cy="6858000"/>
   <p:notesSz cx="6858000" cy="9144000"/>
@@ -118,7 +119,7 @@
 <file path=ppt/revisionInfo.xml><?xml version="1.0" encoding="utf-8"?>
 <p1510:revInfo xmlns:a="http://schemas.openxmlformats.org/drawingml/2006/main" xmlns:r="http://schemas.openxmlformats.org/officeDocument/2006/relationships" xmlns:p1510="http://schemas.microsoft.com/office/powerpoint/2015/10/main">
   <p1510:revLst>
-    <p1510:client id="{27898025-15E3-4451-826A-EBCE81AEFAC6}" v="10" dt="2026-03-09T08:20:19.047"/>
+    <p1510:client id="{27898025-15E3-4451-826A-EBCE81AEFAC6}" v="24" dt="2026-03-16T13:26:26.807"/>
   </p1510:revLst>
 </p1510:revInfo>
 </file>
@@ -127,35 +128,123 @@
 <pc:chgInfo xmlns:a="http://schemas.openxmlformats.org/drawingml/2006/main" xmlns:r="http://schemas.openxmlformats.org/officeDocument/2006/relationships" xmlns:ac="http://schemas.microsoft.com/office/drawing/2013/main/command" xmlns:pc="http://schemas.microsoft.com/office/powerpoint/2013/main/command">
   <pc:docChgLst>
     <pc:chgData name="Jacques Delort" userId="338bbbaa6367577a" providerId="LiveId" clId="{29EEF4E2-F752-45CC-A7DF-F1AD94B64117}"/>
-    <pc:docChg chg="undo custSel addSld modSld">
-      <pc:chgData name="Jacques Delort" userId="338bbbaa6367577a" providerId="LiveId" clId="{29EEF4E2-F752-45CC-A7DF-F1AD94B64117}" dt="2026-03-12T14:59:48.166" v="186" actId="14100"/>
+    <pc:docChg chg="undo redo custSel addSld modSld">
+      <pc:chgData name="Jacques Delort" userId="338bbbaa6367577a" providerId="LiveId" clId="{29EEF4E2-F752-45CC-A7DF-F1AD94B64117}" dt="2026-03-16T13:26:34.717" v="378" actId="14100"/>
       <pc:docMkLst>
         <pc:docMk/>
       </pc:docMkLst>
       <pc:sldChg chg="addSp delSp modSp new mod">
-        <pc:chgData name="Jacques Delort" userId="338bbbaa6367577a" providerId="LiveId" clId="{29EEF4E2-F752-45CC-A7DF-F1AD94B64117}" dt="2026-03-12T14:59:48.166" v="186" actId="14100"/>
+        <pc:chgData name="Jacques Delort" userId="338bbbaa6367577a" providerId="LiveId" clId="{29EEF4E2-F752-45CC-A7DF-F1AD94B64117}" dt="2026-03-16T07:49:56.358" v="359" actId="20577"/>
         <pc:sldMkLst>
           <pc:docMk/>
           <pc:sldMk cId="4164847936" sldId="256"/>
         </pc:sldMkLst>
+        <pc:spChg chg="add del">
+          <ac:chgData name="Jacques Delort" userId="338bbbaa6367577a" providerId="LiveId" clId="{29EEF4E2-F752-45CC-A7DF-F1AD94B64117}" dt="2026-03-16T07:23:23.058" v="201" actId="478"/>
+          <ac:spMkLst>
+            <pc:docMk/>
+            <pc:sldMk cId="4164847936" sldId="256"/>
+            <ac:spMk id="2" creationId="{895A0DE1-0AF3-FDE6-42F3-6A334B0210C7}"/>
+          </ac:spMkLst>
+        </pc:spChg>
+        <pc:spChg chg="add del">
+          <ac:chgData name="Jacques Delort" userId="338bbbaa6367577a" providerId="LiveId" clId="{29EEF4E2-F752-45CC-A7DF-F1AD94B64117}" dt="2026-03-16T07:23:52.012" v="203" actId="11529"/>
+          <ac:spMkLst>
+            <pc:docMk/>
+            <pc:sldMk cId="4164847936" sldId="256"/>
+            <ac:spMk id="3" creationId="{1C12BEA2-8288-3E54-9F73-18255E2AB5DA}"/>
+          </ac:spMkLst>
+        </pc:spChg>
+        <pc:spChg chg="add del">
+          <ac:chgData name="Jacques Delort" userId="338bbbaa6367577a" providerId="LiveId" clId="{29EEF4E2-F752-45CC-A7DF-F1AD94B64117}" dt="2026-03-16T07:24:57.452" v="207" actId="478"/>
+          <ac:spMkLst>
+            <pc:docMk/>
+            <pc:sldMk cId="4164847936" sldId="256"/>
+            <ac:spMk id="4" creationId="{8092A207-B854-B556-D447-292199470B3E}"/>
+          </ac:spMkLst>
+        </pc:spChg>
         <pc:spChg chg="add mod">
-          <ac:chgData name="Jacques Delort" userId="338bbbaa6367577a" providerId="LiveId" clId="{29EEF4E2-F752-45CC-A7DF-F1AD94B64117}" dt="2026-03-12T14:59:00.357" v="172" actId="1076"/>
+          <ac:chgData name="Jacques Delort" userId="338bbbaa6367577a" providerId="LiveId" clId="{29EEF4E2-F752-45CC-A7DF-F1AD94B64117}" dt="2026-03-16T07:29:10.468" v="270" actId="164"/>
           <ac:spMkLst>
             <pc:docMk/>
             <pc:sldMk cId="4164847936" sldId="256"/>
             <ac:spMk id="6" creationId="{30FC81EF-5BD2-CF55-C8A4-1ED90F42C921}"/>
           </ac:spMkLst>
         </pc:spChg>
-        <pc:spChg chg="add del mod">
-          <ac:chgData name="Jacques Delort" userId="338bbbaa6367577a" providerId="LiveId" clId="{29EEF4E2-F752-45CC-A7DF-F1AD94B64117}" dt="2026-03-12T14:58:55.097" v="171" actId="478"/>
+        <pc:spChg chg="add del">
+          <ac:chgData name="Jacques Delort" userId="338bbbaa6367577a" providerId="LiveId" clId="{29EEF4E2-F752-45CC-A7DF-F1AD94B64117}" dt="2026-03-16T07:25:31.406" v="210" actId="11529"/>
           <ac:spMkLst>
             <pc:docMk/>
             <pc:sldMk cId="4164847936" sldId="256"/>
-            <ac:spMk id="32" creationId="{3B80BEB3-5FBB-9BC6-EEB8-F0E55FDCD194}"/>
+            <ac:spMk id="10" creationId="{923A94CB-6F3E-6B4E-23F2-C15D42AD0A54}"/>
           </ac:spMkLst>
         </pc:spChg>
         <pc:spChg chg="add mod">
-          <ac:chgData name="Jacques Delort" userId="338bbbaa6367577a" providerId="LiveId" clId="{29EEF4E2-F752-45CC-A7DF-F1AD94B64117}" dt="2026-03-12T14:59:40.004" v="184" actId="1036"/>
+          <ac:chgData name="Jacques Delort" userId="338bbbaa6367577a" providerId="LiveId" clId="{29EEF4E2-F752-45CC-A7DF-F1AD94B64117}" dt="2026-03-16T07:30:21.490" v="273" actId="1076"/>
+          <ac:spMkLst>
+            <pc:docMk/>
+            <pc:sldMk cId="4164847936" sldId="256"/>
+            <ac:spMk id="23" creationId="{0BCBF898-93E8-7E2B-AEEB-1E92761A125E}"/>
+          </ac:spMkLst>
+        </pc:spChg>
+        <pc:spChg chg="add mod">
+          <ac:chgData name="Jacques Delort" userId="338bbbaa6367577a" providerId="LiveId" clId="{29EEF4E2-F752-45CC-A7DF-F1AD94B64117}" dt="2026-03-16T07:30:21.490" v="273" actId="1076"/>
+          <ac:spMkLst>
+            <pc:docMk/>
+            <pc:sldMk cId="4164847936" sldId="256"/>
+            <ac:spMk id="24" creationId="{3D2EC7D3-76E1-45F4-1488-C5BFA7B44EA4}"/>
+          </ac:spMkLst>
+        </pc:spChg>
+        <pc:spChg chg="add mod">
+          <ac:chgData name="Jacques Delort" userId="338bbbaa6367577a" providerId="LiveId" clId="{29EEF4E2-F752-45CC-A7DF-F1AD94B64117}" dt="2026-03-16T07:30:21.490" v="273" actId="1076"/>
+          <ac:spMkLst>
+            <pc:docMk/>
+            <pc:sldMk cId="4164847936" sldId="256"/>
+            <ac:spMk id="25" creationId="{F282D6EC-E6FC-8BFE-F373-9F6C323CCC40}"/>
+          </ac:spMkLst>
+        </pc:spChg>
+        <pc:spChg chg="add mod">
+          <ac:chgData name="Jacques Delort" userId="338bbbaa6367577a" providerId="LiveId" clId="{29EEF4E2-F752-45CC-A7DF-F1AD94B64117}" dt="2026-03-16T07:30:21.490" v="273" actId="1076"/>
+          <ac:spMkLst>
+            <pc:docMk/>
+            <pc:sldMk cId="4164847936" sldId="256"/>
+            <ac:spMk id="26" creationId="{CF3C00FF-9D2E-9183-2E03-928116E4D52F}"/>
+          </ac:spMkLst>
+        </pc:spChg>
+        <pc:spChg chg="add mod">
+          <ac:chgData name="Jacques Delort" userId="338bbbaa6367577a" providerId="LiveId" clId="{29EEF4E2-F752-45CC-A7DF-F1AD94B64117}" dt="2026-03-16T07:30:21.490" v="273" actId="1076"/>
+          <ac:spMkLst>
+            <pc:docMk/>
+            <pc:sldMk cId="4164847936" sldId="256"/>
+            <ac:spMk id="27" creationId="{30884BC3-8A95-A48C-F107-1C13880A3AF1}"/>
+          </ac:spMkLst>
+        </pc:spChg>
+        <pc:spChg chg="add del mod">
+          <ac:chgData name="Jacques Delort" userId="338bbbaa6367577a" providerId="LiveId" clId="{29EEF4E2-F752-45CC-A7DF-F1AD94B64117}" dt="2026-03-16T07:43:19.859" v="354" actId="478"/>
+          <ac:spMkLst>
+            <pc:docMk/>
+            <pc:sldMk cId="4164847936" sldId="256"/>
+            <ac:spMk id="30" creationId="{4054A4EA-47C0-8DC1-78A1-E30B166D1442}"/>
+          </ac:spMkLst>
+        </pc:spChg>
+        <pc:spChg chg="add del mod">
+          <ac:chgData name="Jacques Delort" userId="338bbbaa6367577a" providerId="LiveId" clId="{29EEF4E2-F752-45CC-A7DF-F1AD94B64117}" dt="2026-03-16T07:43:19.859" v="354" actId="478"/>
+          <ac:spMkLst>
+            <pc:docMk/>
+            <pc:sldMk cId="4164847936" sldId="256"/>
+            <ac:spMk id="31" creationId="{3135ADEE-D746-AC07-7125-D1ED28B7D2DB}"/>
+          </ac:spMkLst>
+        </pc:spChg>
+        <pc:spChg chg="add del mod">
+          <ac:chgData name="Jacques Delort" userId="338bbbaa6367577a" providerId="LiveId" clId="{29EEF4E2-F752-45CC-A7DF-F1AD94B64117}" dt="2026-03-16T07:43:19.859" v="354" actId="478"/>
+          <ac:spMkLst>
+            <pc:docMk/>
+            <pc:sldMk cId="4164847936" sldId="256"/>
+            <ac:spMk id="32" creationId="{CA5B18AB-9356-21B2-7B8F-95474DC61BDE}"/>
+          </ac:spMkLst>
+        </pc:spChg>
+        <pc:spChg chg="add mod">
+          <ac:chgData name="Jacques Delort" userId="338bbbaa6367577a" providerId="LiveId" clId="{29EEF4E2-F752-45CC-A7DF-F1AD94B64117}" dt="2026-03-16T07:29:10.468" v="270" actId="164"/>
           <ac:spMkLst>
             <pc:docMk/>
             <pc:sldMk cId="4164847936" sldId="256"/>
@@ -163,29 +252,148 @@
           </ac:spMkLst>
         </pc:spChg>
         <pc:spChg chg="add mod">
-          <ac:chgData name="Jacques Delort" userId="338bbbaa6367577a" providerId="LiveId" clId="{29EEF4E2-F752-45CC-A7DF-F1AD94B64117}" dt="2026-03-12T14:59:25.786" v="178" actId="1036"/>
+          <ac:chgData name="Jacques Delort" userId="338bbbaa6367577a" providerId="LiveId" clId="{29EEF4E2-F752-45CC-A7DF-F1AD94B64117}" dt="2026-03-16T07:29:10.468" v="270" actId="164"/>
           <ac:spMkLst>
             <pc:docMk/>
             <pc:sldMk cId="4164847936" sldId="256"/>
             <ac:spMk id="34" creationId="{9E06503B-7BAA-5B66-D789-ACFF62E81E20}"/>
           </ac:spMkLst>
         </pc:spChg>
+        <pc:spChg chg="add del mod">
+          <ac:chgData name="Jacques Delort" userId="338bbbaa6367577a" providerId="LiveId" clId="{29EEF4E2-F752-45CC-A7DF-F1AD94B64117}" dt="2026-03-16T07:43:19.859" v="354" actId="478"/>
+          <ac:spMkLst>
+            <pc:docMk/>
+            <pc:sldMk cId="4164847936" sldId="256"/>
+            <ac:spMk id="35" creationId="{3C860175-C08E-BA7D-7D6C-DA022A59B753}"/>
+          </ac:spMkLst>
+        </pc:spChg>
+        <pc:spChg chg="add mod">
+          <ac:chgData name="Jacques Delort" userId="338bbbaa6367577a" providerId="LiveId" clId="{29EEF4E2-F752-45CC-A7DF-F1AD94B64117}" dt="2026-03-16T07:49:56.358" v="359" actId="20577"/>
+          <ac:spMkLst>
+            <pc:docMk/>
+            <pc:sldMk cId="4164847936" sldId="256"/>
+            <ac:spMk id="38" creationId="{8A47F62B-8412-7176-97CE-A4C6804647DB}"/>
+          </ac:spMkLst>
+        </pc:spChg>
+        <pc:grpChg chg="add mod">
+          <ac:chgData name="Jacques Delort" userId="338bbbaa6367577a" providerId="LiveId" clId="{29EEF4E2-F752-45CC-A7DF-F1AD94B64117}" dt="2026-03-16T07:29:15.330" v="272" actId="1076"/>
+          <ac:grpSpMkLst>
+            <pc:docMk/>
+            <pc:sldMk cId="4164847936" sldId="256"/>
+            <ac:grpSpMk id="28" creationId="{EE124DAB-2B84-D7FC-C53E-9CCC09E65ECC}"/>
+          </ac:grpSpMkLst>
+        </pc:grpChg>
         <pc:cxnChg chg="add del mod">
-          <ac:chgData name="Jacques Delort" userId="338bbbaa6367577a" providerId="LiveId" clId="{29EEF4E2-F752-45CC-A7DF-F1AD94B64117}" dt="2026-03-12T14:59:05.457" v="173" actId="478"/>
+          <ac:chgData name="Jacques Delort" userId="338bbbaa6367577a" providerId="LiveId" clId="{29EEF4E2-F752-45CC-A7DF-F1AD94B64117}" dt="2026-03-16T07:25:01.644" v="208" actId="478"/>
           <ac:cxnSpMkLst>
             <pc:docMk/>
             <pc:sldMk cId="4164847936" sldId="256"/>
-            <ac:cxnSpMk id="4" creationId="{98ABC3DA-3309-0A01-5160-80E3D5CE4E3F}"/>
+            <ac:cxnSpMk id="7" creationId="{BAE5FBF8-8949-A653-D2EA-BC890B861FED}"/>
+          </ac:cxnSpMkLst>
+        </pc:cxnChg>
+        <pc:cxnChg chg="add del">
+          <ac:chgData name="Jacques Delort" userId="338bbbaa6367577a" providerId="LiveId" clId="{29EEF4E2-F752-45CC-A7DF-F1AD94B64117}" dt="2026-03-16T07:25:01.644" v="208" actId="478"/>
+          <ac:cxnSpMkLst>
+            <pc:docMk/>
+            <pc:sldMk cId="4164847936" sldId="256"/>
+            <ac:cxnSpMk id="9" creationId="{A0F81E40-9266-FFF9-77F5-1864F9F377F7}"/>
           </ac:cxnSpMkLst>
         </pc:cxnChg>
         <pc:cxnChg chg="add mod">
-          <ac:chgData name="Jacques Delort" userId="338bbbaa6367577a" providerId="LiveId" clId="{29EEF4E2-F752-45CC-A7DF-F1AD94B64117}" dt="2026-03-12T14:59:48.166" v="186" actId="14100"/>
+          <ac:chgData name="Jacques Delort" userId="338bbbaa6367577a" providerId="LiveId" clId="{29EEF4E2-F752-45CC-A7DF-F1AD94B64117}" dt="2026-03-16T07:30:21.490" v="273" actId="1076"/>
+          <ac:cxnSpMkLst>
+            <pc:docMk/>
+            <pc:sldMk cId="4164847936" sldId="256"/>
+            <ac:cxnSpMk id="12" creationId="{DA1F8F11-05D2-653C-F366-D3C8C4BEC9C2}"/>
+          </ac:cxnSpMkLst>
+        </pc:cxnChg>
+        <pc:cxnChg chg="add mod">
+          <ac:chgData name="Jacques Delort" userId="338bbbaa6367577a" providerId="LiveId" clId="{29EEF4E2-F752-45CC-A7DF-F1AD94B64117}" dt="2026-03-16T07:49:30.955" v="355" actId="14100"/>
+          <ac:cxnSpMkLst>
+            <pc:docMk/>
+            <pc:sldMk cId="4164847936" sldId="256"/>
+            <ac:cxnSpMk id="14" creationId="{B60B2F2B-E7E1-8613-16E2-48BA53B1B5C7}"/>
+          </ac:cxnSpMkLst>
+        </pc:cxnChg>
+        <pc:cxnChg chg="add mod">
+          <ac:chgData name="Jacques Delort" userId="338bbbaa6367577a" providerId="LiveId" clId="{29EEF4E2-F752-45CC-A7DF-F1AD94B64117}" dt="2026-03-16T07:30:29.050" v="274" actId="14100"/>
+          <ac:cxnSpMkLst>
+            <pc:docMk/>
+            <pc:sldMk cId="4164847936" sldId="256"/>
+            <ac:cxnSpMk id="16" creationId="{7D96E2E6-778E-6F32-4232-B5E4E284336E}"/>
+          </ac:cxnSpMkLst>
+        </pc:cxnChg>
+        <pc:cxnChg chg="add mod">
+          <ac:chgData name="Jacques Delort" userId="338bbbaa6367577a" providerId="LiveId" clId="{29EEF4E2-F752-45CC-A7DF-F1AD94B64117}" dt="2026-03-16T07:30:21.490" v="273" actId="1076"/>
+          <ac:cxnSpMkLst>
+            <pc:docMk/>
+            <pc:sldMk cId="4164847936" sldId="256"/>
+            <ac:cxnSpMk id="19" creationId="{12C87975-8F05-98BB-80AE-D0CD996CA311}"/>
+          </ac:cxnSpMkLst>
+        </pc:cxnChg>
+        <pc:cxnChg chg="add mod">
+          <ac:chgData name="Jacques Delort" userId="338bbbaa6367577a" providerId="LiveId" clId="{29EEF4E2-F752-45CC-A7DF-F1AD94B64117}" dt="2026-03-16T07:30:21.490" v="273" actId="1076"/>
+          <ac:cxnSpMkLst>
+            <pc:docMk/>
+            <pc:sldMk cId="4164847936" sldId="256"/>
+            <ac:cxnSpMk id="20" creationId="{C9DEAFC3-FA5E-E3F9-4517-004CF0935FF5}"/>
+          </ac:cxnSpMkLst>
+        </pc:cxnChg>
+        <pc:cxnChg chg="add mod">
+          <ac:chgData name="Jacques Delort" userId="338bbbaa6367577a" providerId="LiveId" clId="{29EEF4E2-F752-45CC-A7DF-F1AD94B64117}" dt="2026-03-16T07:29:10.468" v="270" actId="164"/>
           <ac:cxnSpMkLst>
             <pc:docMk/>
             <pc:sldMk cId="4164847936" sldId="256"/>
             <ac:cxnSpMk id="36" creationId="{2B433686-D63C-2008-0A5F-CCAD2C826A5A}"/>
           </ac:cxnSpMkLst>
         </pc:cxnChg>
+      </pc:sldChg>
+      <pc:sldChg chg="addSp delSp modSp new mod">
+        <pc:chgData name="Jacques Delort" userId="338bbbaa6367577a" providerId="LiveId" clId="{29EEF4E2-F752-45CC-A7DF-F1AD94B64117}" dt="2026-03-16T13:26:34.717" v="378" actId="14100"/>
+        <pc:sldMkLst>
+          <pc:docMk/>
+          <pc:sldMk cId="2181586670" sldId="257"/>
+        </pc:sldMkLst>
+        <pc:spChg chg="del">
+          <ac:chgData name="Jacques Delort" userId="338bbbaa6367577a" providerId="LiveId" clId="{29EEF4E2-F752-45CC-A7DF-F1AD94B64117}" dt="2026-03-16T09:54:35.697" v="361" actId="478"/>
+          <ac:spMkLst>
+            <pc:docMk/>
+            <pc:sldMk cId="2181586670" sldId="257"/>
+            <ac:spMk id="2" creationId="{52339C74-C800-4106-0620-A3B355A3D62F}"/>
+          </ac:spMkLst>
+        </pc:spChg>
+        <pc:spChg chg="del">
+          <ac:chgData name="Jacques Delort" userId="338bbbaa6367577a" providerId="LiveId" clId="{29EEF4E2-F752-45CC-A7DF-F1AD94B64117}" dt="2026-03-16T09:54:35.697" v="361" actId="478"/>
+          <ac:spMkLst>
+            <pc:docMk/>
+            <pc:sldMk cId="2181586670" sldId="257"/>
+            <ac:spMk id="3" creationId="{814C6CF0-730B-CA85-9260-4B6F70617038}"/>
+          </ac:spMkLst>
+        </pc:spChg>
+        <pc:spChg chg="add mod">
+          <ac:chgData name="Jacques Delort" userId="338bbbaa6367577a" providerId="LiveId" clId="{29EEF4E2-F752-45CC-A7DF-F1AD94B64117}" dt="2026-03-16T13:26:26.807" v="377" actId="164"/>
+          <ac:spMkLst>
+            <pc:docMk/>
+            <pc:sldMk cId="2181586670" sldId="257"/>
+            <ac:spMk id="6" creationId="{660ED36C-9008-EF2C-36F1-36A9E6FCC7CF}"/>
+          </ac:spMkLst>
+        </pc:spChg>
+        <pc:grpChg chg="add mod">
+          <ac:chgData name="Jacques Delort" userId="338bbbaa6367577a" providerId="LiveId" clId="{29EEF4E2-F752-45CC-A7DF-F1AD94B64117}" dt="2026-03-16T13:26:34.717" v="378" actId="14100"/>
+          <ac:grpSpMkLst>
+            <pc:docMk/>
+            <pc:sldMk cId="2181586670" sldId="257"/>
+            <ac:grpSpMk id="7" creationId="{D7C78ACF-93CE-07F5-8476-8C49626C5C46}"/>
+          </ac:grpSpMkLst>
+        </pc:grpChg>
+        <pc:picChg chg="add del mod">
+          <ac:chgData name="Jacques Delort" userId="338bbbaa6367577a" providerId="LiveId" clId="{29EEF4E2-F752-45CC-A7DF-F1AD94B64117}" dt="2026-03-16T13:26:26.807" v="377" actId="164"/>
+          <ac:picMkLst>
+            <pc:docMk/>
+            <pc:sldMk cId="2181586670" sldId="257"/>
+            <ac:picMk id="5" creationId="{B3A6CCEC-9779-D728-5938-B8A2018F85AC}"/>
+          </ac:picMkLst>
+        </pc:picChg>
       </pc:sldChg>
     </pc:docChg>
   </pc:docChgLst>
@@ -274,7 +482,7 @@
           <a:p>
             <a:fld id="{1FCC755A-E4A9-472B-9F9E-A9F73C19AD1B}" type="datetimeFigureOut">
               <a:rPr lang="fr-FR" smtClean="0"/>
-              <a:t>12/03/2026</a:t>
+              <a:t>16/03/2026</a:t>
             </a:fld>
             <a:endParaRPr lang="fr-FR"/>
           </a:p>
@@ -772,7 +980,7 @@
           <a:p>
             <a:fld id="{FDD8E558-C07A-436E-9726-A2B3122036E2}" type="datetimeFigureOut">
               <a:rPr lang="fr-FR" smtClean="0"/>
-              <a:t>12/03/2026</a:t>
+              <a:t>16/03/2026</a:t>
             </a:fld>
             <a:endParaRPr lang="fr-FR"/>
           </a:p>
@@ -970,7 +1178,7 @@
           <a:p>
             <a:fld id="{FDD8E558-C07A-436E-9726-A2B3122036E2}" type="datetimeFigureOut">
               <a:rPr lang="fr-FR" smtClean="0"/>
-              <a:t>12/03/2026</a:t>
+              <a:t>16/03/2026</a:t>
             </a:fld>
             <a:endParaRPr lang="fr-FR"/>
           </a:p>
@@ -1178,7 +1386,7 @@
           <a:p>
             <a:fld id="{FDD8E558-C07A-436E-9726-A2B3122036E2}" type="datetimeFigureOut">
               <a:rPr lang="fr-FR" smtClean="0"/>
-              <a:t>12/03/2026</a:t>
+              <a:t>16/03/2026</a:t>
             </a:fld>
             <a:endParaRPr lang="fr-FR"/>
           </a:p>
@@ -1376,7 +1584,7 @@
           <a:p>
             <a:fld id="{FDD8E558-C07A-436E-9726-A2B3122036E2}" type="datetimeFigureOut">
               <a:rPr lang="fr-FR" smtClean="0"/>
-              <a:t>12/03/2026</a:t>
+              <a:t>16/03/2026</a:t>
             </a:fld>
             <a:endParaRPr lang="fr-FR"/>
           </a:p>
@@ -1651,7 +1859,7 @@
           <a:p>
             <a:fld id="{FDD8E558-C07A-436E-9726-A2B3122036E2}" type="datetimeFigureOut">
               <a:rPr lang="fr-FR" smtClean="0"/>
-              <a:t>12/03/2026</a:t>
+              <a:t>16/03/2026</a:t>
             </a:fld>
             <a:endParaRPr lang="fr-FR"/>
           </a:p>
@@ -1916,7 +2124,7 @@
           <a:p>
             <a:fld id="{FDD8E558-C07A-436E-9726-A2B3122036E2}" type="datetimeFigureOut">
               <a:rPr lang="fr-FR" smtClean="0"/>
-              <a:t>12/03/2026</a:t>
+              <a:t>16/03/2026</a:t>
             </a:fld>
             <a:endParaRPr lang="fr-FR"/>
           </a:p>
@@ -2328,7 +2536,7 @@
           <a:p>
             <a:fld id="{FDD8E558-C07A-436E-9726-A2B3122036E2}" type="datetimeFigureOut">
               <a:rPr lang="fr-FR" smtClean="0"/>
-              <a:t>12/03/2026</a:t>
+              <a:t>16/03/2026</a:t>
             </a:fld>
             <a:endParaRPr lang="fr-FR"/>
           </a:p>
@@ -2469,7 +2677,7 @@
           <a:p>
             <a:fld id="{FDD8E558-C07A-436E-9726-A2B3122036E2}" type="datetimeFigureOut">
               <a:rPr lang="fr-FR" smtClean="0"/>
-              <a:t>12/03/2026</a:t>
+              <a:t>16/03/2026</a:t>
             </a:fld>
             <a:endParaRPr lang="fr-FR"/>
           </a:p>
@@ -2582,7 +2790,7 @@
           <a:p>
             <a:fld id="{FDD8E558-C07A-436E-9726-A2B3122036E2}" type="datetimeFigureOut">
               <a:rPr lang="fr-FR" smtClean="0"/>
-              <a:t>12/03/2026</a:t>
+              <a:t>16/03/2026</a:t>
             </a:fld>
             <a:endParaRPr lang="fr-FR"/>
           </a:p>
@@ -2893,7 +3101,7 @@
           <a:p>
             <a:fld id="{FDD8E558-C07A-436E-9726-A2B3122036E2}" type="datetimeFigureOut">
               <a:rPr lang="fr-FR" smtClean="0"/>
-              <a:t>12/03/2026</a:t>
+              <a:t>16/03/2026</a:t>
             </a:fld>
             <a:endParaRPr lang="fr-FR"/>
           </a:p>
@@ -3181,7 +3389,7 @@
           <a:p>
             <a:fld id="{FDD8E558-C07A-436E-9726-A2B3122036E2}" type="datetimeFigureOut">
               <a:rPr lang="fr-FR" smtClean="0"/>
-              <a:t>12/03/2026</a:t>
+              <a:t>16/03/2026</a:t>
             </a:fld>
             <a:endParaRPr lang="fr-FR"/>
           </a:p>
@@ -3422,7 +3630,7 @@
           <a:p>
             <a:fld id="{FDD8E558-C07A-436E-9726-A2B3122036E2}" type="datetimeFigureOut">
               <a:rPr lang="fr-FR" smtClean="0"/>
-              <a:t>12/03/2026</a:t>
+              <a:t>16/03/2026</a:t>
             </a:fld>
             <a:endParaRPr lang="fr-FR"/>
           </a:p>
@@ -3839,118 +4047,459 @@
           <a:chExt cx="0" cy="0"/>
         </a:xfrm>
       </p:grpSpPr>
-      <p:sp>
-        <p:nvSpPr>
-          <p:cNvPr id="33" name="Ellipse 32">
-            <a:extLst>
-              <a:ext uri="{FF2B5EF4-FFF2-40B4-BE49-F238E27FC236}">
-                <a16:creationId xmlns:a16="http://schemas.microsoft.com/office/drawing/2014/main" id="{14BE3A2E-4596-6897-D01D-7A80132AB997}"/>
-              </a:ext>
-            </a:extLst>
-          </p:cNvPr>
-          <p:cNvSpPr/>
+      <p:grpSp>
+        <p:nvGrpSpPr>
+          <p:cNvPr id="28" name="Groupe 27">
+            <a:extLst>
+              <a:ext uri="{FF2B5EF4-FFF2-40B4-BE49-F238E27FC236}">
+                <a16:creationId xmlns:a16="http://schemas.microsoft.com/office/drawing/2014/main" id="{EE124DAB-2B84-D7FC-C53E-9CCC09E65ECC}"/>
+              </a:ext>
+            </a:extLst>
+          </p:cNvPr>
+          <p:cNvGrpSpPr/>
           <p:nvPr/>
-        </p:nvSpPr>
+        </p:nvGrpSpPr>
+        <p:grpSpPr>
+          <a:xfrm>
+            <a:off x="552320" y="777205"/>
+            <a:ext cx="5544616" cy="2053938"/>
+            <a:chOff x="47328" y="2959238"/>
+            <a:chExt cx="7859417" cy="3062050"/>
+          </a:xfrm>
+        </p:grpSpPr>
+        <p:sp>
+          <p:nvSpPr>
+            <p:cNvPr id="33" name="Ellipse 32">
+              <a:extLst>
+                <a:ext uri="{FF2B5EF4-FFF2-40B4-BE49-F238E27FC236}">
+                  <a16:creationId xmlns:a16="http://schemas.microsoft.com/office/drawing/2014/main" id="{14BE3A2E-4596-6897-D01D-7A80132AB997}"/>
+                </a:ext>
+              </a:extLst>
+            </p:cNvPr>
+            <p:cNvSpPr/>
+            <p:nvPr/>
+          </p:nvSpPr>
+          <p:spPr>
+            <a:xfrm>
+              <a:off x="47328" y="3861048"/>
+              <a:ext cx="72008" cy="72008"/>
+            </a:xfrm>
+            <a:prstGeom prst="ellipse">
+              <a:avLst/>
+            </a:prstGeom>
+          </p:spPr>
+          <p:style>
+            <a:lnRef idx="2">
+              <a:schemeClr val="accent2">
+                <a:shade val="15000"/>
+              </a:schemeClr>
+            </a:lnRef>
+            <a:fillRef idx="1">
+              <a:schemeClr val="accent2"/>
+            </a:fillRef>
+            <a:effectRef idx="0">
+              <a:schemeClr val="accent2"/>
+            </a:effectRef>
+            <a:fontRef idx="minor">
+              <a:schemeClr val="lt1"/>
+            </a:fontRef>
+          </p:style>
+          <p:txBody>
+            <a:bodyPr rtlCol="0" anchor="ctr"/>
+            <a:lstStyle/>
+            <a:p>
+              <a:pPr algn="ctr"/>
+              <a:endParaRPr lang="fr-FR"/>
+            </a:p>
+          </p:txBody>
+        </p:sp>
+        <p:sp>
+          <p:nvSpPr>
+            <p:cNvPr id="34" name="Ellipse 33">
+              <a:extLst>
+                <a:ext uri="{FF2B5EF4-FFF2-40B4-BE49-F238E27FC236}">
+                  <a16:creationId xmlns:a16="http://schemas.microsoft.com/office/drawing/2014/main" id="{9E06503B-7BAA-5B66-D789-ACFF62E81E20}"/>
+                </a:ext>
+              </a:extLst>
+            </p:cNvPr>
+            <p:cNvSpPr/>
+            <p:nvPr/>
+          </p:nvSpPr>
+          <p:spPr>
+            <a:xfrm>
+              <a:off x="7834737" y="5949280"/>
+              <a:ext cx="72008" cy="72008"/>
+            </a:xfrm>
+            <a:prstGeom prst="ellipse">
+              <a:avLst/>
+            </a:prstGeom>
+          </p:spPr>
+          <p:style>
+            <a:lnRef idx="2">
+              <a:schemeClr val="accent2">
+                <a:shade val="15000"/>
+              </a:schemeClr>
+            </a:lnRef>
+            <a:fillRef idx="1">
+              <a:schemeClr val="accent2"/>
+            </a:fillRef>
+            <a:effectRef idx="0">
+              <a:schemeClr val="accent2"/>
+            </a:effectRef>
+            <a:fontRef idx="minor">
+              <a:schemeClr val="lt1"/>
+            </a:fontRef>
+          </p:style>
+          <p:txBody>
+            <a:bodyPr rtlCol="0" anchor="ctr"/>
+            <a:lstStyle/>
+            <a:p>
+              <a:pPr algn="ctr"/>
+              <a:endParaRPr lang="fr-FR"/>
+            </a:p>
+          </p:txBody>
+        </p:sp>
+        <p:cxnSp>
+          <p:nvCxnSpPr>
+            <p:cNvPr id="36" name="Connecteur droit 35">
+              <a:extLst>
+                <a:ext uri="{FF2B5EF4-FFF2-40B4-BE49-F238E27FC236}">
+                  <a16:creationId xmlns:a16="http://schemas.microsoft.com/office/drawing/2014/main" id="{2B433686-D63C-2008-0A5F-CCAD2C826A5A}"/>
+                </a:ext>
+              </a:extLst>
+            </p:cNvPr>
+            <p:cNvCxnSpPr>
+              <a:cxnSpLocks/>
+              <a:stCxn id="33" idx="6"/>
+              <a:endCxn id="34" idx="2"/>
+            </p:cNvCxnSpPr>
+            <p:nvPr/>
+          </p:nvCxnSpPr>
+          <p:spPr>
+            <a:xfrm>
+              <a:off x="119336" y="3897052"/>
+              <a:ext cx="7715401" cy="2088232"/>
+            </a:xfrm>
+            <a:prstGeom prst="line">
+              <a:avLst/>
+            </a:prstGeom>
+          </p:spPr>
+          <p:style>
+            <a:lnRef idx="2">
+              <a:schemeClr val="accent2"/>
+            </a:lnRef>
+            <a:fillRef idx="0">
+              <a:schemeClr val="accent2"/>
+            </a:fillRef>
+            <a:effectRef idx="1">
+              <a:schemeClr val="accent2"/>
+            </a:effectRef>
+            <a:fontRef idx="minor">
+              <a:schemeClr val="tx1"/>
+            </a:fontRef>
+          </p:style>
+        </p:cxnSp>
+        <p:sp>
+          <p:nvSpPr>
+            <p:cNvPr id="6" name="Forme libre : forme 5">
+              <a:extLst>
+                <a:ext uri="{FF2B5EF4-FFF2-40B4-BE49-F238E27FC236}">
+                  <a16:creationId xmlns:a16="http://schemas.microsoft.com/office/drawing/2014/main" id="{30FC81EF-5BD2-CF55-C8A4-1ED90F42C921}"/>
+                </a:ext>
+              </a:extLst>
+            </p:cNvPr>
+            <p:cNvSpPr/>
+            <p:nvPr/>
+          </p:nvSpPr>
+          <p:spPr>
+            <a:xfrm>
+              <a:off x="371364" y="2959238"/>
+              <a:ext cx="6996702" cy="2568539"/>
+            </a:xfrm>
+            <a:custGeom>
+              <a:avLst/>
+              <a:gdLst>
+                <a:gd name="csX0" fmla="*/ 0 w 6996702"/>
+                <a:gd name="csY0" fmla="*/ 904126 h 2568539"/>
+                <a:gd name="csX1" fmla="*/ 267129 w 6996702"/>
+                <a:gd name="csY1" fmla="*/ 349321 h 2568539"/>
+                <a:gd name="csX2" fmla="*/ 729466 w 6996702"/>
+                <a:gd name="csY2" fmla="*/ 791110 h 2568539"/>
+                <a:gd name="csX3" fmla="*/ 688369 w 6996702"/>
+                <a:gd name="csY3" fmla="*/ 164386 h 2568539"/>
+                <a:gd name="csX4" fmla="*/ 1109609 w 6996702"/>
+                <a:gd name="csY4" fmla="*/ 832206 h 2568539"/>
+                <a:gd name="csX5" fmla="*/ 1181529 w 6996702"/>
+                <a:gd name="csY5" fmla="*/ 174660 h 2568539"/>
+                <a:gd name="csX6" fmla="*/ 1571946 w 6996702"/>
+                <a:gd name="csY6" fmla="*/ 688368 h 2568539"/>
+                <a:gd name="csX7" fmla="*/ 1993187 w 6996702"/>
+                <a:gd name="csY7" fmla="*/ 61645 h 2568539"/>
+                <a:gd name="csX8" fmla="*/ 3328827 w 6996702"/>
+                <a:gd name="csY8" fmla="*/ 0 h 2568539"/>
+                <a:gd name="csX9" fmla="*/ 4335695 w 6996702"/>
+                <a:gd name="csY9" fmla="*/ 195209 h 2568539"/>
+                <a:gd name="csX10" fmla="*/ 5599416 w 6996702"/>
+                <a:gd name="csY10" fmla="*/ 431514 h 2568539"/>
+                <a:gd name="csX11" fmla="*/ 5948737 w 6996702"/>
+                <a:gd name="csY11" fmla="*/ 1325366 h 2568539"/>
+                <a:gd name="csX12" fmla="*/ 6359704 w 6996702"/>
+                <a:gd name="csY12" fmla="*/ 2157573 h 2568539"/>
+                <a:gd name="csX13" fmla="*/ 6996702 w 6996702"/>
+                <a:gd name="csY13" fmla="*/ 2568539 h 2568539"/>
+              </a:gdLst>
+              <a:ahLst/>
+              <a:cxnLst>
+                <a:cxn ang="0">
+                  <a:pos x="csX0" y="csY0"/>
+                </a:cxn>
+                <a:cxn ang="0">
+                  <a:pos x="csX1" y="csY1"/>
+                </a:cxn>
+                <a:cxn ang="0">
+                  <a:pos x="csX2" y="csY2"/>
+                </a:cxn>
+                <a:cxn ang="0">
+                  <a:pos x="csX3" y="csY3"/>
+                </a:cxn>
+                <a:cxn ang="0">
+                  <a:pos x="csX4" y="csY4"/>
+                </a:cxn>
+                <a:cxn ang="0">
+                  <a:pos x="csX5" y="csY5"/>
+                </a:cxn>
+                <a:cxn ang="0">
+                  <a:pos x="csX6" y="csY6"/>
+                </a:cxn>
+                <a:cxn ang="0">
+                  <a:pos x="csX7" y="csY7"/>
+                </a:cxn>
+                <a:cxn ang="0">
+                  <a:pos x="csX8" y="csY8"/>
+                </a:cxn>
+                <a:cxn ang="0">
+                  <a:pos x="csX9" y="csY9"/>
+                </a:cxn>
+                <a:cxn ang="0">
+                  <a:pos x="csX10" y="csY10"/>
+                </a:cxn>
+                <a:cxn ang="0">
+                  <a:pos x="csX11" y="csY11"/>
+                </a:cxn>
+                <a:cxn ang="0">
+                  <a:pos x="csX12" y="csY12"/>
+                </a:cxn>
+                <a:cxn ang="0">
+                  <a:pos x="csX13" y="csY13"/>
+                </a:cxn>
+              </a:cxnLst>
+              <a:rect l="l" t="t" r="r" b="b"/>
+              <a:pathLst>
+                <a:path w="6996702" h="2568539">
+                  <a:moveTo>
+                    <a:pt x="0" y="904126"/>
+                  </a:moveTo>
+                  <a:lnTo>
+                    <a:pt x="267129" y="349321"/>
+                  </a:lnTo>
+                  <a:lnTo>
+                    <a:pt x="729466" y="791110"/>
+                  </a:lnTo>
+                  <a:lnTo>
+                    <a:pt x="688369" y="164386"/>
+                  </a:lnTo>
+                  <a:lnTo>
+                    <a:pt x="1109609" y="832206"/>
+                  </a:lnTo>
+                  <a:lnTo>
+                    <a:pt x="1181529" y="174660"/>
+                  </a:lnTo>
+                  <a:lnTo>
+                    <a:pt x="1571946" y="688368"/>
+                  </a:lnTo>
+                  <a:lnTo>
+                    <a:pt x="1993187" y="61645"/>
+                  </a:lnTo>
+                  <a:lnTo>
+                    <a:pt x="3328827" y="0"/>
+                  </a:lnTo>
+                  <a:lnTo>
+                    <a:pt x="4335695" y="195209"/>
+                  </a:lnTo>
+                  <a:lnTo>
+                    <a:pt x="5599416" y="431514"/>
+                  </a:lnTo>
+                  <a:lnTo>
+                    <a:pt x="5948737" y="1325366"/>
+                  </a:lnTo>
+                  <a:lnTo>
+                    <a:pt x="6359704" y="2157573"/>
+                  </a:lnTo>
+                  <a:lnTo>
+                    <a:pt x="6996702" y="2568539"/>
+                  </a:lnTo>
+                </a:path>
+              </a:pathLst>
+            </a:custGeom>
+            <a:noFill/>
+          </p:spPr>
+          <p:style>
+            <a:lnRef idx="2">
+              <a:schemeClr val="accent1">
+                <a:shade val="15000"/>
+              </a:schemeClr>
+            </a:lnRef>
+            <a:fillRef idx="1">
+              <a:schemeClr val="accent1"/>
+            </a:fillRef>
+            <a:effectRef idx="0">
+              <a:schemeClr val="accent1"/>
+            </a:effectRef>
+            <a:fontRef idx="minor">
+              <a:schemeClr val="lt1"/>
+            </a:fontRef>
+          </p:style>
+          <p:txBody>
+            <a:bodyPr rtlCol="0" anchor="ctr"/>
+            <a:lstStyle/>
+            <a:p>
+              <a:pPr algn="ctr"/>
+              <a:endParaRPr lang="fr-FR"/>
+            </a:p>
+          </p:txBody>
+        </p:sp>
+      </p:grpSp>
+      <p:cxnSp>
+        <p:nvCxnSpPr>
+          <p:cNvPr id="12" name="Connecteur droit 11">
+            <a:extLst>
+              <a:ext uri="{FF2B5EF4-FFF2-40B4-BE49-F238E27FC236}">
+                <a16:creationId xmlns:a16="http://schemas.microsoft.com/office/drawing/2014/main" id="{DA1F8F11-05D2-653C-F366-D3C8C4BEC9C2}"/>
+              </a:ext>
+            </a:extLst>
+          </p:cNvPr>
+          <p:cNvCxnSpPr/>
+          <p:nvPr/>
+        </p:nvCxnSpPr>
         <p:spPr>
-          <a:xfrm>
-            <a:off x="983432" y="3284984"/>
-            <a:ext cx="72008" cy="72008"/>
+          <a:xfrm flipV="1">
+            <a:off x="8309031" y="3412708"/>
+            <a:ext cx="720080" cy="1440160"/>
           </a:xfrm>
-          <a:prstGeom prst="ellipse">
+          <a:prstGeom prst="line">
             <a:avLst/>
           </a:prstGeom>
         </p:spPr>
         <p:style>
           <a:lnRef idx="2">
-            <a:schemeClr val="accent2">
-              <a:shade val="15000"/>
-            </a:schemeClr>
+            <a:schemeClr val="accent1"/>
           </a:lnRef>
-          <a:fillRef idx="1">
-            <a:schemeClr val="accent2"/>
+          <a:fillRef idx="0">
+            <a:schemeClr val="accent1"/>
           </a:fillRef>
-          <a:effectRef idx="0">
-            <a:schemeClr val="accent2"/>
+          <a:effectRef idx="1">
+            <a:schemeClr val="accent1"/>
           </a:effectRef>
           <a:fontRef idx="minor">
-            <a:schemeClr val="lt1"/>
+            <a:schemeClr val="tx1"/>
           </a:fontRef>
         </p:style>
-        <p:txBody>
-          <a:bodyPr rtlCol="0" anchor="ctr"/>
-          <a:lstStyle/>
-          <a:p>
-            <a:pPr algn="ctr"/>
-            <a:endParaRPr lang="fr-FR"/>
-          </a:p>
-        </p:txBody>
-      </p:sp>
-      <p:sp>
-        <p:nvSpPr>
-          <p:cNvPr id="34" name="Ellipse 33">
-            <a:extLst>
-              <a:ext uri="{FF2B5EF4-FFF2-40B4-BE49-F238E27FC236}">
-                <a16:creationId xmlns:a16="http://schemas.microsoft.com/office/drawing/2014/main" id="{9E06503B-7BAA-5B66-D789-ACFF62E81E20}"/>
-              </a:ext>
-            </a:extLst>
-          </p:cNvPr>
-          <p:cNvSpPr/>
+      </p:cxnSp>
+      <p:cxnSp>
+        <p:nvCxnSpPr>
+          <p:cNvPr id="14" name="Connecteur droit 13">
+            <a:extLst>
+              <a:ext uri="{FF2B5EF4-FFF2-40B4-BE49-F238E27FC236}">
+                <a16:creationId xmlns:a16="http://schemas.microsoft.com/office/drawing/2014/main" id="{B60B2F2B-E7E1-8613-16E2-48BA53B1B5C7}"/>
+              </a:ext>
+            </a:extLst>
+          </p:cNvPr>
+          <p:cNvCxnSpPr>
+            <a:cxnSpLocks/>
+          </p:cNvCxnSpPr>
           <p:nvPr/>
-        </p:nvSpPr>
+        </p:nvCxnSpPr>
         <p:spPr>
           <a:xfrm>
-            <a:off x="8482809" y="5373216"/>
-            <a:ext cx="72008" cy="72008"/>
+            <a:off x="9029111" y="3412708"/>
+            <a:ext cx="2146803" cy="1476164"/>
           </a:xfrm>
-          <a:prstGeom prst="ellipse">
+          <a:prstGeom prst="line">
             <a:avLst/>
           </a:prstGeom>
         </p:spPr>
         <p:style>
           <a:lnRef idx="2">
-            <a:schemeClr val="accent2">
-              <a:shade val="15000"/>
-            </a:schemeClr>
+            <a:schemeClr val="accent1"/>
           </a:lnRef>
-          <a:fillRef idx="1">
-            <a:schemeClr val="accent2"/>
+          <a:fillRef idx="0">
+            <a:schemeClr val="accent1"/>
           </a:fillRef>
-          <a:effectRef idx="0">
-            <a:schemeClr val="accent2"/>
+          <a:effectRef idx="1">
+            <a:schemeClr val="accent1"/>
           </a:effectRef>
           <a:fontRef idx="minor">
-            <a:schemeClr val="lt1"/>
+            <a:schemeClr val="tx1"/>
           </a:fontRef>
         </p:style>
-        <p:txBody>
-          <a:bodyPr rtlCol="0" anchor="ctr"/>
-          <a:lstStyle/>
-          <a:p>
-            <a:pPr algn="ctr"/>
-            <a:endParaRPr lang="fr-FR"/>
-          </a:p>
-        </p:txBody>
-      </p:sp>
+      </p:cxnSp>
       <p:cxnSp>
         <p:nvCxnSpPr>
-          <p:cNvPr id="36" name="Connecteur droit 35">
-            <a:extLst>
-              <a:ext uri="{FF2B5EF4-FFF2-40B4-BE49-F238E27FC236}">
-                <a16:creationId xmlns:a16="http://schemas.microsoft.com/office/drawing/2014/main" id="{2B433686-D63C-2008-0A5F-CCAD2C826A5A}"/>
+          <p:cNvPr id="16" name="Connecteur droit 15">
+            <a:extLst>
+              <a:ext uri="{FF2B5EF4-FFF2-40B4-BE49-F238E27FC236}">
+                <a16:creationId xmlns:a16="http://schemas.microsoft.com/office/drawing/2014/main" id="{7D96E2E6-778E-6F32-4232-B5E4E284336E}"/>
               </a:ext>
             </a:extLst>
           </p:cNvPr>
           <p:cNvCxnSpPr>
             <a:cxnSpLocks/>
-            <a:stCxn id="33" idx="5"/>
-            <a:endCxn id="34" idx="2"/>
           </p:cNvCxnSpPr>
           <p:nvPr/>
         </p:nvCxnSpPr>
         <p:spPr>
           <a:xfrm>
-            <a:off x="1044895" y="3346447"/>
-            <a:ext cx="7437914" cy="2062773"/>
+            <a:off x="7536160" y="565770"/>
+            <a:ext cx="2200530" cy="4287098"/>
+          </a:xfrm>
+          <a:prstGeom prst="line">
+            <a:avLst/>
+          </a:prstGeom>
+          <a:ln>
+            <a:prstDash val="sysDash"/>
+          </a:ln>
+        </p:spPr>
+        <p:style>
+          <a:lnRef idx="2">
+            <a:schemeClr val="accent1"/>
+          </a:lnRef>
+          <a:fillRef idx="0">
+            <a:schemeClr val="accent1"/>
+          </a:fillRef>
+          <a:effectRef idx="1">
+            <a:schemeClr val="accent1"/>
+          </a:effectRef>
+          <a:fontRef idx="minor">
+            <a:schemeClr val="tx1"/>
+          </a:fontRef>
+        </p:style>
+      </p:cxnSp>
+      <p:cxnSp>
+        <p:nvCxnSpPr>
+          <p:cNvPr id="19" name="Connecteur droit 18">
+            <a:extLst>
+              <a:ext uri="{FF2B5EF4-FFF2-40B4-BE49-F238E27FC236}">
+                <a16:creationId xmlns:a16="http://schemas.microsoft.com/office/drawing/2014/main" id="{12C87975-8F05-98BB-80AE-D0CD996CA311}"/>
+              </a:ext>
+            </a:extLst>
+          </p:cNvPr>
+          <p:cNvCxnSpPr/>
+          <p:nvPr/>
+        </p:nvCxnSpPr>
+        <p:spPr>
+          <a:xfrm flipV="1">
+            <a:off x="8309031" y="2692628"/>
+            <a:ext cx="360040" cy="2160240"/>
           </a:xfrm>
           <a:prstGeom prst="line">
             <a:avLst/>
@@ -3971,172 +4520,251 @@
           </a:fontRef>
         </p:style>
       </p:cxnSp>
-      <p:sp>
-        <p:nvSpPr>
-          <p:cNvPr id="6" name="Forme libre : forme 5">
-            <a:extLst>
-              <a:ext uri="{FF2B5EF4-FFF2-40B4-BE49-F238E27FC236}">
-                <a16:creationId xmlns:a16="http://schemas.microsoft.com/office/drawing/2014/main" id="{30FC81EF-5BD2-CF55-C8A4-1ED90F42C921}"/>
-              </a:ext>
-            </a:extLst>
-          </p:cNvPr>
-          <p:cNvSpPr/>
+      <p:cxnSp>
+        <p:nvCxnSpPr>
+          <p:cNvPr id="20" name="Connecteur droit 19">
+            <a:extLst>
+              <a:ext uri="{FF2B5EF4-FFF2-40B4-BE49-F238E27FC236}">
+                <a16:creationId xmlns:a16="http://schemas.microsoft.com/office/drawing/2014/main" id="{C9DEAFC3-FA5E-E3F9-4517-004CF0935FF5}"/>
+              </a:ext>
+            </a:extLst>
+          </p:cNvPr>
+          <p:cNvCxnSpPr>
+            <a:cxnSpLocks/>
+          </p:cNvCxnSpPr>
           <p:nvPr/>
-        </p:nvSpPr>
+        </p:nvCxnSpPr>
         <p:spPr>
-          <a:xfrm>
-            <a:off x="1019436" y="2383174"/>
-            <a:ext cx="6996702" cy="2568539"/>
+          <a:xfrm flipH="1" flipV="1">
+            <a:off x="8668958" y="2708920"/>
+            <a:ext cx="2520393" cy="2179952"/>
           </a:xfrm>
-          <a:custGeom>
+          <a:prstGeom prst="line">
             <a:avLst/>
-            <a:gdLst>
-              <a:gd name="csX0" fmla="*/ 0 w 6996702"/>
-              <a:gd name="csY0" fmla="*/ 904126 h 2568539"/>
-              <a:gd name="csX1" fmla="*/ 267129 w 6996702"/>
-              <a:gd name="csY1" fmla="*/ 349321 h 2568539"/>
-              <a:gd name="csX2" fmla="*/ 729466 w 6996702"/>
-              <a:gd name="csY2" fmla="*/ 791110 h 2568539"/>
-              <a:gd name="csX3" fmla="*/ 688369 w 6996702"/>
-              <a:gd name="csY3" fmla="*/ 164386 h 2568539"/>
-              <a:gd name="csX4" fmla="*/ 1109609 w 6996702"/>
-              <a:gd name="csY4" fmla="*/ 832206 h 2568539"/>
-              <a:gd name="csX5" fmla="*/ 1181529 w 6996702"/>
-              <a:gd name="csY5" fmla="*/ 174660 h 2568539"/>
-              <a:gd name="csX6" fmla="*/ 1571946 w 6996702"/>
-              <a:gd name="csY6" fmla="*/ 688368 h 2568539"/>
-              <a:gd name="csX7" fmla="*/ 1993187 w 6996702"/>
-              <a:gd name="csY7" fmla="*/ 61645 h 2568539"/>
-              <a:gd name="csX8" fmla="*/ 3328827 w 6996702"/>
-              <a:gd name="csY8" fmla="*/ 0 h 2568539"/>
-              <a:gd name="csX9" fmla="*/ 4335695 w 6996702"/>
-              <a:gd name="csY9" fmla="*/ 195209 h 2568539"/>
-              <a:gd name="csX10" fmla="*/ 5599416 w 6996702"/>
-              <a:gd name="csY10" fmla="*/ 431514 h 2568539"/>
-              <a:gd name="csX11" fmla="*/ 5948737 w 6996702"/>
-              <a:gd name="csY11" fmla="*/ 1325366 h 2568539"/>
-              <a:gd name="csX12" fmla="*/ 6359704 w 6996702"/>
-              <a:gd name="csY12" fmla="*/ 2157573 h 2568539"/>
-              <a:gd name="csX13" fmla="*/ 6996702 w 6996702"/>
-              <a:gd name="csY13" fmla="*/ 2568539 h 2568539"/>
-            </a:gdLst>
-            <a:ahLst/>
-            <a:cxnLst>
-              <a:cxn ang="0">
-                <a:pos x="csX0" y="csY0"/>
-              </a:cxn>
-              <a:cxn ang="0">
-                <a:pos x="csX1" y="csY1"/>
-              </a:cxn>
-              <a:cxn ang="0">
-                <a:pos x="csX2" y="csY2"/>
-              </a:cxn>
-              <a:cxn ang="0">
-                <a:pos x="csX3" y="csY3"/>
-              </a:cxn>
-              <a:cxn ang="0">
-                <a:pos x="csX4" y="csY4"/>
-              </a:cxn>
-              <a:cxn ang="0">
-                <a:pos x="csX5" y="csY5"/>
-              </a:cxn>
-              <a:cxn ang="0">
-                <a:pos x="csX6" y="csY6"/>
-              </a:cxn>
-              <a:cxn ang="0">
-                <a:pos x="csX7" y="csY7"/>
-              </a:cxn>
-              <a:cxn ang="0">
-                <a:pos x="csX8" y="csY8"/>
-              </a:cxn>
-              <a:cxn ang="0">
-                <a:pos x="csX9" y="csY9"/>
-              </a:cxn>
-              <a:cxn ang="0">
-                <a:pos x="csX10" y="csY10"/>
-              </a:cxn>
-              <a:cxn ang="0">
-                <a:pos x="csX11" y="csY11"/>
-              </a:cxn>
-              <a:cxn ang="0">
-                <a:pos x="csX12" y="csY12"/>
-              </a:cxn>
-              <a:cxn ang="0">
-                <a:pos x="csX13" y="csY13"/>
-              </a:cxn>
-            </a:cxnLst>
-            <a:rect l="l" t="t" r="r" b="b"/>
-            <a:pathLst>
-              <a:path w="6996702" h="2568539">
-                <a:moveTo>
-                  <a:pt x="0" y="904126"/>
-                </a:moveTo>
-                <a:lnTo>
-                  <a:pt x="267129" y="349321"/>
-                </a:lnTo>
-                <a:lnTo>
-                  <a:pt x="729466" y="791110"/>
-                </a:lnTo>
-                <a:lnTo>
-                  <a:pt x="688369" y="164386"/>
-                </a:lnTo>
-                <a:lnTo>
-                  <a:pt x="1109609" y="832206"/>
-                </a:lnTo>
-                <a:lnTo>
-                  <a:pt x="1181529" y="174660"/>
-                </a:lnTo>
-                <a:lnTo>
-                  <a:pt x="1571946" y="688368"/>
-                </a:lnTo>
-                <a:lnTo>
-                  <a:pt x="1993187" y="61645"/>
-                </a:lnTo>
-                <a:lnTo>
-                  <a:pt x="3328827" y="0"/>
-                </a:lnTo>
-                <a:lnTo>
-                  <a:pt x="4335695" y="195209"/>
-                </a:lnTo>
-                <a:lnTo>
-                  <a:pt x="5599416" y="431514"/>
-                </a:lnTo>
-                <a:lnTo>
-                  <a:pt x="5948737" y="1325366"/>
-                </a:lnTo>
-                <a:lnTo>
-                  <a:pt x="6359704" y="2157573"/>
-                </a:lnTo>
-                <a:lnTo>
-                  <a:pt x="6996702" y="2568539"/>
-                </a:lnTo>
-              </a:path>
-            </a:pathLst>
-          </a:custGeom>
-          <a:noFill/>
+          </a:prstGeom>
         </p:spPr>
         <p:style>
           <a:lnRef idx="2">
-            <a:schemeClr val="accent1">
-              <a:shade val="15000"/>
-            </a:schemeClr>
+            <a:schemeClr val="accent2"/>
           </a:lnRef>
-          <a:fillRef idx="1">
-            <a:schemeClr val="accent1"/>
+          <a:fillRef idx="0">
+            <a:schemeClr val="accent2"/>
           </a:fillRef>
-          <a:effectRef idx="0">
-            <a:schemeClr val="accent1"/>
+          <a:effectRef idx="1">
+            <a:schemeClr val="accent2"/>
           </a:effectRef>
           <a:fontRef idx="minor">
-            <a:schemeClr val="lt1"/>
+            <a:schemeClr val="tx1"/>
           </a:fontRef>
         </p:style>
-        <p:txBody>
-          <a:bodyPr rtlCol="0" anchor="ctr"/>
-          <a:lstStyle/>
-          <a:p>
-            <a:pPr algn="ctr"/>
-            <a:endParaRPr lang="fr-FR"/>
+      </p:cxnSp>
+      <p:sp>
+        <p:nvSpPr>
+          <p:cNvPr id="23" name="ZoneTexte 22">
+            <a:extLst>
+              <a:ext uri="{FF2B5EF4-FFF2-40B4-BE49-F238E27FC236}">
+                <a16:creationId xmlns:a16="http://schemas.microsoft.com/office/drawing/2014/main" id="{0BCBF898-93E8-7E2B-AEEB-1E92761A125E}"/>
+              </a:ext>
+            </a:extLst>
+          </p:cNvPr>
+          <p:cNvSpPr txBox="1"/>
+          <p:nvPr/>
+        </p:nvSpPr>
+        <p:spPr>
+          <a:xfrm>
+            <a:off x="8120853" y="4852868"/>
+            <a:ext cx="479979" cy="369332"/>
+          </a:xfrm>
+          <a:prstGeom prst="rect">
+            <a:avLst/>
+          </a:prstGeom>
+          <a:noFill/>
+        </p:spPr>
+        <p:txBody>
+          <a:bodyPr wrap="square" rtlCol="0">
+            <a:spAutoFit/>
+          </a:bodyPr>
+          <a:lstStyle/>
+          <a:p>
+            <a:r>
+              <a:rPr lang="fr-FR" dirty="0"/>
+              <a:t>A</a:t>
+            </a:r>
+          </a:p>
+        </p:txBody>
+      </p:sp>
+      <p:sp>
+        <p:nvSpPr>
+          <p:cNvPr id="24" name="ZoneTexte 23">
+            <a:extLst>
+              <a:ext uri="{FF2B5EF4-FFF2-40B4-BE49-F238E27FC236}">
+                <a16:creationId xmlns:a16="http://schemas.microsoft.com/office/drawing/2014/main" id="{3D2EC7D3-76E1-45F4-1488-C5BFA7B44EA4}"/>
+              </a:ext>
+            </a:extLst>
+          </p:cNvPr>
+          <p:cNvSpPr txBox="1"/>
+          <p:nvPr/>
+        </p:nvSpPr>
+        <p:spPr>
+          <a:xfrm>
+            <a:off x="11017487" y="4831889"/>
+            <a:ext cx="479979" cy="369332"/>
+          </a:xfrm>
+          <a:prstGeom prst="rect">
+            <a:avLst/>
+          </a:prstGeom>
+          <a:noFill/>
+        </p:spPr>
+        <p:txBody>
+          <a:bodyPr wrap="square" rtlCol="0">
+            <a:spAutoFit/>
+          </a:bodyPr>
+          <a:lstStyle/>
+          <a:p>
+            <a:r>
+              <a:rPr lang="fr-FR" dirty="0"/>
+              <a:t>C</a:t>
+            </a:r>
+          </a:p>
+        </p:txBody>
+      </p:sp>
+      <p:sp>
+        <p:nvSpPr>
+          <p:cNvPr id="25" name="ZoneTexte 24">
+            <a:extLst>
+              <a:ext uri="{FF2B5EF4-FFF2-40B4-BE49-F238E27FC236}">
+                <a16:creationId xmlns:a16="http://schemas.microsoft.com/office/drawing/2014/main" id="{F282D6EC-E6FC-8BFE-F373-9F6C323CCC40}"/>
+              </a:ext>
+            </a:extLst>
+          </p:cNvPr>
+          <p:cNvSpPr txBox="1"/>
+          <p:nvPr/>
+        </p:nvSpPr>
+        <p:spPr>
+          <a:xfrm>
+            <a:off x="8653938" y="3228042"/>
+            <a:ext cx="479979" cy="369332"/>
+          </a:xfrm>
+          <a:prstGeom prst="rect">
+            <a:avLst/>
+          </a:prstGeom>
+          <a:noFill/>
+        </p:spPr>
+        <p:txBody>
+          <a:bodyPr wrap="square" rtlCol="0">
+            <a:spAutoFit/>
+          </a:bodyPr>
+          <a:lstStyle/>
+          <a:p>
+            <a:r>
+              <a:rPr lang="fr-FR" dirty="0"/>
+              <a:t>B</a:t>
+            </a:r>
+          </a:p>
+        </p:txBody>
+      </p:sp>
+      <p:sp>
+        <p:nvSpPr>
+          <p:cNvPr id="26" name="ZoneTexte 25">
+            <a:extLst>
+              <a:ext uri="{FF2B5EF4-FFF2-40B4-BE49-F238E27FC236}">
+                <a16:creationId xmlns:a16="http://schemas.microsoft.com/office/drawing/2014/main" id="{CF3C00FF-9D2E-9183-2E03-928116E4D52F}"/>
+              </a:ext>
+            </a:extLst>
+          </p:cNvPr>
+          <p:cNvSpPr txBox="1"/>
+          <p:nvPr/>
+        </p:nvSpPr>
+        <p:spPr>
+          <a:xfrm>
+            <a:off x="8662293" y="2334093"/>
+            <a:ext cx="479979" cy="369332"/>
+          </a:xfrm>
+          <a:prstGeom prst="rect">
+            <a:avLst/>
+          </a:prstGeom>
+          <a:noFill/>
+        </p:spPr>
+        <p:txBody>
+          <a:bodyPr wrap="square" rtlCol="0">
+            <a:spAutoFit/>
+          </a:bodyPr>
+          <a:lstStyle/>
+          <a:p>
+            <a:r>
+              <a:rPr lang="fr-FR" dirty="0"/>
+              <a:t>B’</a:t>
+            </a:r>
+          </a:p>
+        </p:txBody>
+      </p:sp>
+      <p:sp>
+        <p:nvSpPr>
+          <p:cNvPr id="27" name="ZoneTexte 26">
+            <a:extLst>
+              <a:ext uri="{FF2B5EF4-FFF2-40B4-BE49-F238E27FC236}">
+                <a16:creationId xmlns:a16="http://schemas.microsoft.com/office/drawing/2014/main" id="{30884BC3-8A95-A48C-F107-1C13880A3AF1}"/>
+              </a:ext>
+            </a:extLst>
+          </p:cNvPr>
+          <p:cNvSpPr txBox="1"/>
+          <p:nvPr/>
+        </p:nvSpPr>
+        <p:spPr>
+          <a:xfrm>
+            <a:off x="9615607" y="4818689"/>
+            <a:ext cx="479979" cy="369332"/>
+          </a:xfrm>
+          <a:prstGeom prst="rect">
+            <a:avLst/>
+          </a:prstGeom>
+          <a:noFill/>
+        </p:spPr>
+        <p:txBody>
+          <a:bodyPr wrap="square" rtlCol="0">
+            <a:spAutoFit/>
+          </a:bodyPr>
+          <a:lstStyle/>
+          <a:p>
+            <a:r>
+              <a:rPr lang="fr-FR" dirty="0"/>
+              <a:t>M</a:t>
+            </a:r>
+          </a:p>
+        </p:txBody>
+      </p:sp>
+      <p:sp>
+        <p:nvSpPr>
+          <p:cNvPr id="38" name="ZoneTexte 37">
+            <a:extLst>
+              <a:ext uri="{FF2B5EF4-FFF2-40B4-BE49-F238E27FC236}">
+                <a16:creationId xmlns:a16="http://schemas.microsoft.com/office/drawing/2014/main" id="{8A47F62B-8412-7176-97CE-A4C6804647DB}"/>
+              </a:ext>
+            </a:extLst>
+          </p:cNvPr>
+          <p:cNvSpPr txBox="1"/>
+          <p:nvPr/>
+        </p:nvSpPr>
+        <p:spPr>
+          <a:xfrm>
+            <a:off x="8840464" y="4870576"/>
+            <a:ext cx="479979" cy="369332"/>
+          </a:xfrm>
+          <a:prstGeom prst="rect">
+            <a:avLst/>
+          </a:prstGeom>
+          <a:noFill/>
+        </p:spPr>
+        <p:txBody>
+          <a:bodyPr wrap="square" rtlCol="0">
+            <a:spAutoFit/>
+          </a:bodyPr>
+          <a:lstStyle/>
+          <a:p>
+            <a:r>
+              <a:rPr lang="fr-FR" dirty="0"/>
+              <a:t>Ha</a:t>
+            </a:r>
           </a:p>
         </p:txBody>
       </p:sp>
@@ -4144,6 +4772,133 @@
     <p:extLst>
       <p:ext uri="{BB962C8B-B14F-4D97-AF65-F5344CB8AC3E}">
         <p14:creationId xmlns:p14="http://schemas.microsoft.com/office/powerpoint/2010/main" val="4164847936"/>
+      </p:ext>
+    </p:extLst>
+  </p:cSld>
+  <p:clrMapOvr>
+    <a:masterClrMapping/>
+  </p:clrMapOvr>
+</p:sld>
+</file>
+
+<file path=ppt/slides/slide2.xml><?xml version="1.0" encoding="utf-8"?>
+<p:sld xmlns:a="http://schemas.openxmlformats.org/drawingml/2006/main" xmlns:r="http://schemas.openxmlformats.org/officeDocument/2006/relationships" xmlns:p="http://schemas.openxmlformats.org/presentationml/2006/main">
+  <p:cSld>
+    <p:spTree>
+      <p:nvGrpSpPr>
+        <p:cNvPr id="1" name=""/>
+        <p:cNvGrpSpPr/>
+        <p:nvPr/>
+      </p:nvGrpSpPr>
+      <p:grpSpPr>
+        <a:xfrm>
+          <a:off x="0" y="0"/>
+          <a:ext cx="0" cy="0"/>
+          <a:chOff x="0" y="0"/>
+          <a:chExt cx="0" cy="0"/>
+        </a:xfrm>
+      </p:grpSpPr>
+      <p:grpSp>
+        <p:nvGrpSpPr>
+          <p:cNvPr id="7" name="Groupe 6">
+            <a:extLst>
+              <a:ext uri="{FF2B5EF4-FFF2-40B4-BE49-F238E27FC236}">
+                <a16:creationId xmlns:a16="http://schemas.microsoft.com/office/drawing/2014/main" id="{D7C78ACF-93CE-07F5-8476-8C49626C5C46}"/>
+              </a:ext>
+            </a:extLst>
+          </p:cNvPr>
+          <p:cNvGrpSpPr/>
+          <p:nvPr/>
+        </p:nvGrpSpPr>
+        <p:grpSpPr>
+          <a:xfrm>
+            <a:off x="54977" y="0"/>
+            <a:ext cx="2512631" cy="6858000"/>
+            <a:chOff x="54977" y="0"/>
+            <a:chExt cx="12082046" cy="6858000"/>
+          </a:xfrm>
+        </p:grpSpPr>
+        <p:pic>
+          <p:nvPicPr>
+            <p:cNvPr id="5" name="Image 4">
+              <a:extLst>
+                <a:ext uri="{FF2B5EF4-FFF2-40B4-BE49-F238E27FC236}">
+                  <a16:creationId xmlns:a16="http://schemas.microsoft.com/office/drawing/2014/main" id="{B3A6CCEC-9779-D728-5938-B8A2018F85AC}"/>
+                </a:ext>
+              </a:extLst>
+            </p:cNvPr>
+            <p:cNvPicPr>
+              <a:picLocks noChangeAspect="1"/>
+            </p:cNvPicPr>
+            <p:nvPr/>
+          </p:nvPicPr>
+          <p:blipFill>
+            <a:blip r:embed="rId2"/>
+            <a:stretch>
+              <a:fillRect/>
+            </a:stretch>
+          </p:blipFill>
+          <p:spPr>
+            <a:xfrm>
+              <a:off x="54977" y="0"/>
+              <a:ext cx="12082046" cy="6858000"/>
+            </a:xfrm>
+            <a:prstGeom prst="rect">
+              <a:avLst/>
+            </a:prstGeom>
+          </p:spPr>
+        </p:pic>
+        <p:sp>
+          <p:nvSpPr>
+            <p:cNvPr id="6" name="Ellipse 5">
+              <a:extLst>
+                <a:ext uri="{FF2B5EF4-FFF2-40B4-BE49-F238E27FC236}">
+                  <a16:creationId xmlns:a16="http://schemas.microsoft.com/office/drawing/2014/main" id="{660ED36C-9008-EF2C-36F1-36A9E6FCC7CF}"/>
+                </a:ext>
+              </a:extLst>
+            </p:cNvPr>
+            <p:cNvSpPr/>
+            <p:nvPr/>
+          </p:nvSpPr>
+          <p:spPr>
+            <a:xfrm>
+              <a:off x="7392144" y="404664"/>
+              <a:ext cx="360040" cy="144016"/>
+            </a:xfrm>
+            <a:prstGeom prst="ellipse">
+              <a:avLst/>
+            </a:prstGeom>
+          </p:spPr>
+          <p:style>
+            <a:lnRef idx="2">
+              <a:schemeClr val="accent1">
+                <a:shade val="15000"/>
+              </a:schemeClr>
+            </a:lnRef>
+            <a:fillRef idx="1">
+              <a:schemeClr val="accent1"/>
+            </a:fillRef>
+            <a:effectRef idx="0">
+              <a:schemeClr val="accent1"/>
+            </a:effectRef>
+            <a:fontRef idx="minor">
+              <a:schemeClr val="lt1"/>
+            </a:fontRef>
+          </p:style>
+          <p:txBody>
+            <a:bodyPr rtlCol="0" anchor="ctr"/>
+            <a:lstStyle/>
+            <a:p>
+              <a:pPr algn="ctr"/>
+              <a:endParaRPr lang="fr-FR"/>
+            </a:p>
+          </p:txBody>
+        </p:sp>
+      </p:grpSp>
+    </p:spTree>
+    <p:extLst>
+      <p:ext uri="{BB962C8B-B14F-4D97-AF65-F5344CB8AC3E}">
+        <p14:creationId xmlns:p14="http://schemas.microsoft.com/office/powerpoint/2010/main" val="2181586670"/>
       </p:ext>
     </p:extLst>
   </p:cSld>

</xml_diff>